<commit_message>
docs: corrigir apresenacao e adicionar pdf
</commit_message>
<xml_diff>
--- a/Apresentacao/Slides_.pptx
+++ b/Apresentacao/Slides_.pptx
@@ -5,29 +5,29 @@
     <p:sldMasterId id="2147483648" r:id="rId1"/>
   </p:sldMasterIdLst>
   <p:sldIdLst>
-    <p:sldId id="256" r:id="rId7"/>
-    <p:sldId id="257" r:id="rId8"/>
-    <p:sldId id="258" r:id="rId9"/>
-    <p:sldId id="259" r:id="rId10"/>
-    <p:sldId id="260" r:id="rId11"/>
-    <p:sldId id="261" r:id="rId12"/>
-    <p:sldId id="262" r:id="rId13"/>
-    <p:sldId id="263" r:id="rId14"/>
-    <p:sldId id="264" r:id="rId15"/>
-    <p:sldId id="265" r:id="rId16"/>
-    <p:sldId id="266" r:id="rId17"/>
-    <p:sldId id="267" r:id="rId18"/>
-    <p:sldId id="268" r:id="rId19"/>
-    <p:sldId id="269" r:id="rId20"/>
-    <p:sldId id="270" r:id="rId21"/>
-    <p:sldId id="271" r:id="rId22"/>
-    <p:sldId id="272" r:id="rId23"/>
-    <p:sldId id="273" r:id="rId24"/>
-    <p:sldId id="274" r:id="rId25"/>
-    <p:sldId id="275" r:id="rId26"/>
-    <p:sldId id="276" r:id="rId27"/>
+    <p:sldId id="256" r:id="rId2"/>
+    <p:sldId id="257" r:id="rId3"/>
+    <p:sldId id="258" r:id="rId4"/>
+    <p:sldId id="278" r:id="rId5"/>
+    <p:sldId id="260" r:id="rId6"/>
+    <p:sldId id="261" r:id="rId7"/>
+    <p:sldId id="262" r:id="rId8"/>
+    <p:sldId id="263" r:id="rId9"/>
+    <p:sldId id="264" r:id="rId10"/>
+    <p:sldId id="265" r:id="rId11"/>
+    <p:sldId id="266" r:id="rId12"/>
+    <p:sldId id="267" r:id="rId13"/>
+    <p:sldId id="268" r:id="rId14"/>
+    <p:sldId id="269" r:id="rId15"/>
+    <p:sldId id="270" r:id="rId16"/>
+    <p:sldId id="271" r:id="rId17"/>
+    <p:sldId id="272" r:id="rId18"/>
+    <p:sldId id="273" r:id="rId19"/>
+    <p:sldId id="274" r:id="rId20"/>
+    <p:sldId id="275" r:id="rId21"/>
+    <p:sldId id="276" r:id="rId22"/>
   </p:sldIdLst>
-  <p:sldSz cx="18288000" cy="10287000" type="screen4x3"/>
+  <p:sldSz cx="18288000" cy="10287000"/>
   <p:notesSz cx="6858000" cy="9144000"/>
   <p:defaultTextStyle>
     <a:defPPr>
@@ -124,6 +124,22 @@
       </a:defRPr>
     </a:lvl9pPr>
   </p:defaultTextStyle>
+  <p:extLst>
+    <p:ext uri="{EFAFB233-063F-42B5-8137-9DF3F51BA10A}">
+      <p15:sldGuideLst xmlns:p15="http://schemas.microsoft.com/office/powerpoint/2012/main">
+        <p15:guide id="1" orient="horz" pos="2160">
+          <p15:clr>
+            <a:srgbClr val="A4A3A4"/>
+          </p15:clr>
+        </p15:guide>
+        <p15:guide id="2" pos="2880">
+          <p15:clr>
+            <a:srgbClr val="A4A3A4"/>
+          </p15:clr>
+        </p15:guide>
+      </p15:sldGuideLst>
+    </p:ext>
+  </p:extLst>
 </p:presentation>
 </file>
 
@@ -165,10 +181,9 @@
           <a:lstStyle/>
           <a:p>
             <a:r>
-              <a:rPr lang="en-US" smtClean="0"/>
+              <a:rPr lang="en-US"/>
               <a:t>Click to edit Master title style</a:t>
             </a:r>
-            <a:endParaRPr lang="en-US"/>
           </a:p>
         </p:txBody>
       </p:sp>
@@ -284,10 +299,9 @@
           </a:lstStyle>
           <a:p>
             <a:r>
-              <a:rPr lang="en-US" smtClean="0"/>
+              <a:rPr lang="en-US"/>
               <a:t>Click to edit Master subtitle style</a:t>
             </a:r>
-            <a:endParaRPr lang="en-US"/>
           </a:p>
         </p:txBody>
       </p:sp>
@@ -308,7 +322,7 @@
           <a:p>
             <a:fld id="{5BCAD085-E8A6-8845-BD4E-CB4CCA059FC4}" type="datetimeFigureOut">
               <a:rPr lang="en-US" smtClean="0"/>
-              <a:t>1/27/13</a:t>
+              <a:t>5/4/2026</a:t>
             </a:fld>
             <a:endParaRPr lang="en-US"/>
           </a:p>
@@ -350,7 +364,7 @@
           <a:p>
             <a:fld id="{C1FF6DA9-008F-8B48-92A6-B652298478BF}" type="slidenum">
               <a:rPr lang="en-US" smtClean="0"/>
-              <a:t>‹#›</a:t>
+              <a:t>‹nº›</a:t>
             </a:fld>
             <a:endParaRPr lang="en-US"/>
           </a:p>
@@ -402,10 +416,9 @@
           <a:lstStyle/>
           <a:p>
             <a:r>
-              <a:rPr lang="en-US" smtClean="0"/>
+              <a:rPr lang="en-US"/>
               <a:t>Click to edit Master title style</a:t>
             </a:r>
-            <a:endParaRPr lang="en-US"/>
           </a:p>
         </p:txBody>
       </p:sp>
@@ -426,38 +439,37 @@
           <a:p>
             <a:pPr lvl="0"/>
             <a:r>
-              <a:rPr lang="en-US" smtClean="0"/>
+              <a:rPr lang="en-US"/>
               <a:t>Click to edit Master text styles</a:t>
             </a:r>
           </a:p>
           <a:p>
             <a:pPr lvl="1"/>
             <a:r>
-              <a:rPr lang="en-US" smtClean="0"/>
+              <a:rPr lang="en-US"/>
               <a:t>Second level</a:t>
             </a:r>
           </a:p>
           <a:p>
             <a:pPr lvl="2"/>
             <a:r>
-              <a:rPr lang="en-US" smtClean="0"/>
+              <a:rPr lang="en-US"/>
               <a:t>Third level</a:t>
             </a:r>
           </a:p>
           <a:p>
             <a:pPr lvl="3"/>
             <a:r>
-              <a:rPr lang="en-US" smtClean="0"/>
+              <a:rPr lang="en-US"/>
               <a:t>Fourth level</a:t>
             </a:r>
           </a:p>
           <a:p>
             <a:pPr lvl="4"/>
             <a:r>
-              <a:rPr lang="en-US" smtClean="0"/>
+              <a:rPr lang="en-US"/>
               <a:t>Fifth level</a:t>
             </a:r>
-            <a:endParaRPr lang="en-US"/>
           </a:p>
         </p:txBody>
       </p:sp>
@@ -478,7 +490,7 @@
           <a:p>
             <a:fld id="{5BCAD085-E8A6-8845-BD4E-CB4CCA059FC4}" type="datetimeFigureOut">
               <a:rPr lang="en-US" smtClean="0"/>
-              <a:t>1/27/13</a:t>
+              <a:t>5/4/2026</a:t>
             </a:fld>
             <a:endParaRPr lang="en-US"/>
           </a:p>
@@ -520,7 +532,7 @@
           <a:p>
             <a:fld id="{C1FF6DA9-008F-8B48-92A6-B652298478BF}" type="slidenum">
               <a:rPr lang="en-US" smtClean="0"/>
-              <a:t>‹#›</a:t>
+              <a:t>‹nº›</a:t>
             </a:fld>
             <a:endParaRPr lang="en-US"/>
           </a:p>
@@ -577,10 +589,9 @@
           <a:lstStyle/>
           <a:p>
             <a:r>
-              <a:rPr lang="en-US" smtClean="0"/>
+              <a:rPr lang="en-US"/>
               <a:t>Click to edit Master title style</a:t>
             </a:r>
-            <a:endParaRPr lang="en-US"/>
           </a:p>
         </p:txBody>
       </p:sp>
@@ -606,38 +617,37 @@
           <a:p>
             <a:pPr lvl="0"/>
             <a:r>
-              <a:rPr lang="en-US" smtClean="0"/>
+              <a:rPr lang="en-US"/>
               <a:t>Click to edit Master text styles</a:t>
             </a:r>
           </a:p>
           <a:p>
             <a:pPr lvl="1"/>
             <a:r>
-              <a:rPr lang="en-US" smtClean="0"/>
+              <a:rPr lang="en-US"/>
               <a:t>Second level</a:t>
             </a:r>
           </a:p>
           <a:p>
             <a:pPr lvl="2"/>
             <a:r>
-              <a:rPr lang="en-US" smtClean="0"/>
+              <a:rPr lang="en-US"/>
               <a:t>Third level</a:t>
             </a:r>
           </a:p>
           <a:p>
             <a:pPr lvl="3"/>
             <a:r>
-              <a:rPr lang="en-US" smtClean="0"/>
+              <a:rPr lang="en-US"/>
               <a:t>Fourth level</a:t>
             </a:r>
           </a:p>
           <a:p>
             <a:pPr lvl="4"/>
             <a:r>
-              <a:rPr lang="en-US" smtClean="0"/>
+              <a:rPr lang="en-US"/>
               <a:t>Fifth level</a:t>
             </a:r>
-            <a:endParaRPr lang="en-US"/>
           </a:p>
         </p:txBody>
       </p:sp>
@@ -658,7 +668,7 @@
           <a:p>
             <a:fld id="{5BCAD085-E8A6-8845-BD4E-CB4CCA059FC4}" type="datetimeFigureOut">
               <a:rPr lang="en-US" smtClean="0"/>
-              <a:t>1/27/13</a:t>
+              <a:t>5/4/2026</a:t>
             </a:fld>
             <a:endParaRPr lang="en-US"/>
           </a:p>
@@ -700,7 +710,7 @@
           <a:p>
             <a:fld id="{C1FF6DA9-008F-8B48-92A6-B652298478BF}" type="slidenum">
               <a:rPr lang="en-US" smtClean="0"/>
-              <a:t>‹#›</a:t>
+              <a:t>‹nº›</a:t>
             </a:fld>
             <a:endParaRPr lang="en-US"/>
           </a:p>
@@ -752,10 +762,9 @@
           <a:lstStyle/>
           <a:p>
             <a:r>
-              <a:rPr lang="en-US" smtClean="0"/>
+              <a:rPr lang="en-US"/>
               <a:t>Click to edit Master title style</a:t>
             </a:r>
-            <a:endParaRPr lang="en-US"/>
           </a:p>
         </p:txBody>
       </p:sp>
@@ -776,38 +785,37 @@
           <a:p>
             <a:pPr lvl="0"/>
             <a:r>
-              <a:rPr lang="en-US" smtClean="0"/>
+              <a:rPr lang="en-US"/>
               <a:t>Click to edit Master text styles</a:t>
             </a:r>
           </a:p>
           <a:p>
             <a:pPr lvl="1"/>
             <a:r>
-              <a:rPr lang="en-US" smtClean="0"/>
+              <a:rPr lang="en-US"/>
               <a:t>Second level</a:t>
             </a:r>
           </a:p>
           <a:p>
             <a:pPr lvl="2"/>
             <a:r>
-              <a:rPr lang="en-US" smtClean="0"/>
+              <a:rPr lang="en-US"/>
               <a:t>Third level</a:t>
             </a:r>
           </a:p>
           <a:p>
             <a:pPr lvl="3"/>
             <a:r>
-              <a:rPr lang="en-US" smtClean="0"/>
+              <a:rPr lang="en-US"/>
               <a:t>Fourth level</a:t>
             </a:r>
           </a:p>
           <a:p>
             <a:pPr lvl="4"/>
             <a:r>
-              <a:rPr lang="en-US" smtClean="0"/>
+              <a:rPr lang="en-US"/>
               <a:t>Fifth level</a:t>
             </a:r>
-            <a:endParaRPr lang="en-US"/>
           </a:p>
         </p:txBody>
       </p:sp>
@@ -828,7 +836,7 @@
           <a:p>
             <a:fld id="{5BCAD085-E8A6-8845-BD4E-CB4CCA059FC4}" type="datetimeFigureOut">
               <a:rPr lang="en-US" smtClean="0"/>
-              <a:t>1/27/13</a:t>
+              <a:t>5/4/2026</a:t>
             </a:fld>
             <a:endParaRPr lang="en-US"/>
           </a:p>
@@ -870,7 +878,7 @@
           <a:p>
             <a:fld id="{C1FF6DA9-008F-8B48-92A6-B652298478BF}" type="slidenum">
               <a:rPr lang="en-US" smtClean="0"/>
-              <a:t>‹#›</a:t>
+              <a:t>‹nº›</a:t>
             </a:fld>
             <a:endParaRPr lang="en-US"/>
           </a:p>
@@ -931,10 +939,9 @@
           </a:lstStyle>
           <a:p>
             <a:r>
-              <a:rPr lang="en-US" smtClean="0"/>
+              <a:rPr lang="en-US"/>
               <a:t>Click to edit Master title style</a:t>
             </a:r>
-            <a:endParaRPr lang="en-US"/>
           </a:p>
         </p:txBody>
       </p:sp>
@@ -1051,7 +1058,7 @@
           <a:p>
             <a:pPr lvl="0"/>
             <a:r>
-              <a:rPr lang="en-US" smtClean="0"/>
+              <a:rPr lang="en-US"/>
               <a:t>Click to edit Master text styles</a:t>
             </a:r>
           </a:p>
@@ -1074,7 +1081,7 @@
           <a:p>
             <a:fld id="{5BCAD085-E8A6-8845-BD4E-CB4CCA059FC4}" type="datetimeFigureOut">
               <a:rPr lang="en-US" smtClean="0"/>
-              <a:t>1/27/13</a:t>
+              <a:t>5/4/2026</a:t>
             </a:fld>
             <a:endParaRPr lang="en-US"/>
           </a:p>
@@ -1116,7 +1123,7 @@
           <a:p>
             <a:fld id="{C1FF6DA9-008F-8B48-92A6-B652298478BF}" type="slidenum">
               <a:rPr lang="en-US" smtClean="0"/>
-              <a:t>‹#›</a:t>
+              <a:t>‹nº›</a:t>
             </a:fld>
             <a:endParaRPr lang="en-US"/>
           </a:p>
@@ -1168,10 +1175,9 @@
           <a:lstStyle/>
           <a:p>
             <a:r>
-              <a:rPr lang="en-US" smtClean="0"/>
+              <a:rPr lang="en-US"/>
               <a:t>Click to edit Master title style</a:t>
             </a:r>
-            <a:endParaRPr lang="en-US"/>
           </a:p>
         </p:txBody>
       </p:sp>
@@ -1225,38 +1231,37 @@
           <a:p>
             <a:pPr lvl="0"/>
             <a:r>
-              <a:rPr lang="en-US" smtClean="0"/>
+              <a:rPr lang="en-US"/>
               <a:t>Click to edit Master text styles</a:t>
             </a:r>
           </a:p>
           <a:p>
             <a:pPr lvl="1"/>
             <a:r>
-              <a:rPr lang="en-US" smtClean="0"/>
+              <a:rPr lang="en-US"/>
               <a:t>Second level</a:t>
             </a:r>
           </a:p>
           <a:p>
             <a:pPr lvl="2"/>
             <a:r>
-              <a:rPr lang="en-US" smtClean="0"/>
+              <a:rPr lang="en-US"/>
               <a:t>Third level</a:t>
             </a:r>
           </a:p>
           <a:p>
             <a:pPr lvl="3"/>
             <a:r>
-              <a:rPr lang="en-US" smtClean="0"/>
+              <a:rPr lang="en-US"/>
               <a:t>Fourth level</a:t>
             </a:r>
           </a:p>
           <a:p>
             <a:pPr lvl="4"/>
             <a:r>
-              <a:rPr lang="en-US" smtClean="0"/>
+              <a:rPr lang="en-US"/>
               <a:t>Fifth level</a:t>
             </a:r>
-            <a:endParaRPr lang="en-US"/>
           </a:p>
         </p:txBody>
       </p:sp>
@@ -1310,38 +1315,37 @@
           <a:p>
             <a:pPr lvl="0"/>
             <a:r>
-              <a:rPr lang="en-US" smtClean="0"/>
+              <a:rPr lang="en-US"/>
               <a:t>Click to edit Master text styles</a:t>
             </a:r>
           </a:p>
           <a:p>
             <a:pPr lvl="1"/>
             <a:r>
-              <a:rPr lang="en-US" smtClean="0"/>
+              <a:rPr lang="en-US"/>
               <a:t>Second level</a:t>
             </a:r>
           </a:p>
           <a:p>
             <a:pPr lvl="2"/>
             <a:r>
-              <a:rPr lang="en-US" smtClean="0"/>
+              <a:rPr lang="en-US"/>
               <a:t>Third level</a:t>
             </a:r>
           </a:p>
           <a:p>
             <a:pPr lvl="3"/>
             <a:r>
-              <a:rPr lang="en-US" smtClean="0"/>
+              <a:rPr lang="en-US"/>
               <a:t>Fourth level</a:t>
             </a:r>
           </a:p>
           <a:p>
             <a:pPr lvl="4"/>
             <a:r>
-              <a:rPr lang="en-US" smtClean="0"/>
+              <a:rPr lang="en-US"/>
               <a:t>Fifth level</a:t>
             </a:r>
-            <a:endParaRPr lang="en-US"/>
           </a:p>
         </p:txBody>
       </p:sp>
@@ -1362,7 +1366,7 @@
           <a:p>
             <a:fld id="{5BCAD085-E8A6-8845-BD4E-CB4CCA059FC4}" type="datetimeFigureOut">
               <a:rPr lang="en-US" smtClean="0"/>
-              <a:t>1/27/13</a:t>
+              <a:t>5/4/2026</a:t>
             </a:fld>
             <a:endParaRPr lang="en-US"/>
           </a:p>
@@ -1404,7 +1408,7 @@
           <a:p>
             <a:fld id="{C1FF6DA9-008F-8B48-92A6-B652298478BF}" type="slidenum">
               <a:rPr lang="en-US" smtClean="0"/>
-              <a:t>‹#›</a:t>
+              <a:t>‹nº›</a:t>
             </a:fld>
             <a:endParaRPr lang="en-US"/>
           </a:p>
@@ -1460,10 +1464,9 @@
           </a:lstStyle>
           <a:p>
             <a:r>
-              <a:rPr lang="en-US" smtClean="0"/>
+              <a:rPr lang="en-US"/>
               <a:t>Click to edit Master title style</a:t>
             </a:r>
-            <a:endParaRPr lang="en-US"/>
           </a:p>
         </p:txBody>
       </p:sp>
@@ -1526,7 +1529,7 @@
           <a:p>
             <a:pPr lvl="0"/>
             <a:r>
-              <a:rPr lang="en-US" smtClean="0"/>
+              <a:rPr lang="en-US"/>
               <a:t>Click to edit Master text styles</a:t>
             </a:r>
           </a:p>
@@ -1582,38 +1585,37 @@
           <a:p>
             <a:pPr lvl="0"/>
             <a:r>
-              <a:rPr lang="en-US" smtClean="0"/>
+              <a:rPr lang="en-US"/>
               <a:t>Click to edit Master text styles</a:t>
             </a:r>
           </a:p>
           <a:p>
             <a:pPr lvl="1"/>
             <a:r>
-              <a:rPr lang="en-US" smtClean="0"/>
+              <a:rPr lang="en-US"/>
               <a:t>Second level</a:t>
             </a:r>
           </a:p>
           <a:p>
             <a:pPr lvl="2"/>
             <a:r>
-              <a:rPr lang="en-US" smtClean="0"/>
+              <a:rPr lang="en-US"/>
               <a:t>Third level</a:t>
             </a:r>
           </a:p>
           <a:p>
             <a:pPr lvl="3"/>
             <a:r>
-              <a:rPr lang="en-US" smtClean="0"/>
+              <a:rPr lang="en-US"/>
               <a:t>Fourth level</a:t>
             </a:r>
           </a:p>
           <a:p>
             <a:pPr lvl="4"/>
             <a:r>
-              <a:rPr lang="en-US" smtClean="0"/>
+              <a:rPr lang="en-US"/>
               <a:t>Fifth level</a:t>
             </a:r>
-            <a:endParaRPr lang="en-US"/>
           </a:p>
         </p:txBody>
       </p:sp>
@@ -1676,7 +1678,7 @@
           <a:p>
             <a:pPr lvl="0"/>
             <a:r>
-              <a:rPr lang="en-US" smtClean="0"/>
+              <a:rPr lang="en-US"/>
               <a:t>Click to edit Master text styles</a:t>
             </a:r>
           </a:p>
@@ -1732,38 +1734,37 @@
           <a:p>
             <a:pPr lvl="0"/>
             <a:r>
-              <a:rPr lang="en-US" smtClean="0"/>
+              <a:rPr lang="en-US"/>
               <a:t>Click to edit Master text styles</a:t>
             </a:r>
           </a:p>
           <a:p>
             <a:pPr lvl="1"/>
             <a:r>
-              <a:rPr lang="en-US" smtClean="0"/>
+              <a:rPr lang="en-US"/>
               <a:t>Second level</a:t>
             </a:r>
           </a:p>
           <a:p>
             <a:pPr lvl="2"/>
             <a:r>
-              <a:rPr lang="en-US" smtClean="0"/>
+              <a:rPr lang="en-US"/>
               <a:t>Third level</a:t>
             </a:r>
           </a:p>
           <a:p>
             <a:pPr lvl="3"/>
             <a:r>
-              <a:rPr lang="en-US" smtClean="0"/>
+              <a:rPr lang="en-US"/>
               <a:t>Fourth level</a:t>
             </a:r>
           </a:p>
           <a:p>
             <a:pPr lvl="4"/>
             <a:r>
-              <a:rPr lang="en-US" smtClean="0"/>
+              <a:rPr lang="en-US"/>
               <a:t>Fifth level</a:t>
             </a:r>
-            <a:endParaRPr lang="en-US"/>
           </a:p>
         </p:txBody>
       </p:sp>
@@ -1784,7 +1785,7 @@
           <a:p>
             <a:fld id="{5BCAD085-E8A6-8845-BD4E-CB4CCA059FC4}" type="datetimeFigureOut">
               <a:rPr lang="en-US" smtClean="0"/>
-              <a:t>1/27/13</a:t>
+              <a:t>5/4/2026</a:t>
             </a:fld>
             <a:endParaRPr lang="en-US"/>
           </a:p>
@@ -1826,7 +1827,7 @@
           <a:p>
             <a:fld id="{C1FF6DA9-008F-8B48-92A6-B652298478BF}" type="slidenum">
               <a:rPr lang="en-US" smtClean="0"/>
-              <a:t>‹#›</a:t>
+              <a:t>‹nº›</a:t>
             </a:fld>
             <a:endParaRPr lang="en-US"/>
           </a:p>
@@ -1878,10 +1879,9 @@
           <a:lstStyle/>
           <a:p>
             <a:r>
-              <a:rPr lang="en-US" smtClean="0"/>
+              <a:rPr lang="en-US"/>
               <a:t>Click to edit Master title style</a:t>
             </a:r>
-            <a:endParaRPr lang="en-US"/>
           </a:p>
         </p:txBody>
       </p:sp>
@@ -1902,7 +1902,7 @@
           <a:p>
             <a:fld id="{5BCAD085-E8A6-8845-BD4E-CB4CCA059FC4}" type="datetimeFigureOut">
               <a:rPr lang="en-US" smtClean="0"/>
-              <a:t>1/27/13</a:t>
+              <a:t>5/4/2026</a:t>
             </a:fld>
             <a:endParaRPr lang="en-US"/>
           </a:p>
@@ -1944,7 +1944,7 @@
           <a:p>
             <a:fld id="{C1FF6DA9-008F-8B48-92A6-B652298478BF}" type="slidenum">
               <a:rPr lang="en-US" smtClean="0"/>
-              <a:t>‹#›</a:t>
+              <a:t>‹nº›</a:t>
             </a:fld>
             <a:endParaRPr lang="en-US"/>
           </a:p>
@@ -1997,7 +1997,7 @@
           <a:p>
             <a:fld id="{5BCAD085-E8A6-8845-BD4E-CB4CCA059FC4}" type="datetimeFigureOut">
               <a:rPr lang="en-US" smtClean="0"/>
-              <a:t>1/27/13</a:t>
+              <a:t>5/4/2026</a:t>
             </a:fld>
             <a:endParaRPr lang="en-US"/>
           </a:p>
@@ -2039,7 +2039,7 @@
           <a:p>
             <a:fld id="{C1FF6DA9-008F-8B48-92A6-B652298478BF}" type="slidenum">
               <a:rPr lang="en-US" smtClean="0"/>
-              <a:t>‹#›</a:t>
+              <a:t>‹nº›</a:t>
             </a:fld>
             <a:endParaRPr lang="en-US"/>
           </a:p>
@@ -2100,10 +2100,9 @@
           </a:lstStyle>
           <a:p>
             <a:r>
-              <a:rPr lang="en-US" smtClean="0"/>
+              <a:rPr lang="en-US"/>
               <a:t>Click to edit Master title style</a:t>
             </a:r>
-            <a:endParaRPr lang="en-US"/>
           </a:p>
         </p:txBody>
       </p:sp>
@@ -2157,38 +2156,37 @@
           <a:p>
             <a:pPr lvl="0"/>
             <a:r>
-              <a:rPr lang="en-US" smtClean="0"/>
+              <a:rPr lang="en-US"/>
               <a:t>Click to edit Master text styles</a:t>
             </a:r>
           </a:p>
           <a:p>
             <a:pPr lvl="1"/>
             <a:r>
-              <a:rPr lang="en-US" smtClean="0"/>
+              <a:rPr lang="en-US"/>
               <a:t>Second level</a:t>
             </a:r>
           </a:p>
           <a:p>
             <a:pPr lvl="2"/>
             <a:r>
-              <a:rPr lang="en-US" smtClean="0"/>
+              <a:rPr lang="en-US"/>
               <a:t>Third level</a:t>
             </a:r>
           </a:p>
           <a:p>
             <a:pPr lvl="3"/>
             <a:r>
-              <a:rPr lang="en-US" smtClean="0"/>
+              <a:rPr lang="en-US"/>
               <a:t>Fourth level</a:t>
             </a:r>
           </a:p>
           <a:p>
             <a:pPr lvl="4"/>
             <a:r>
-              <a:rPr lang="en-US" smtClean="0"/>
+              <a:rPr lang="en-US"/>
               <a:t>Fifth level</a:t>
             </a:r>
-            <a:endParaRPr lang="en-US"/>
           </a:p>
         </p:txBody>
       </p:sp>
@@ -2251,7 +2249,7 @@
           <a:p>
             <a:pPr lvl="0"/>
             <a:r>
-              <a:rPr lang="en-US" smtClean="0"/>
+              <a:rPr lang="en-US"/>
               <a:t>Click to edit Master text styles</a:t>
             </a:r>
           </a:p>
@@ -2274,7 +2272,7 @@
           <a:p>
             <a:fld id="{5BCAD085-E8A6-8845-BD4E-CB4CCA059FC4}" type="datetimeFigureOut">
               <a:rPr lang="en-US" smtClean="0"/>
-              <a:t>1/27/13</a:t>
+              <a:t>5/4/2026</a:t>
             </a:fld>
             <a:endParaRPr lang="en-US"/>
           </a:p>
@@ -2316,7 +2314,7 @@
           <a:p>
             <a:fld id="{C1FF6DA9-008F-8B48-92A6-B652298478BF}" type="slidenum">
               <a:rPr lang="en-US" smtClean="0"/>
-              <a:t>‹#›</a:t>
+              <a:t>‹nº›</a:t>
             </a:fld>
             <a:endParaRPr lang="en-US"/>
           </a:p>
@@ -2377,10 +2375,9 @@
           </a:lstStyle>
           <a:p>
             <a:r>
-              <a:rPr lang="en-US" smtClean="0"/>
+              <a:rPr lang="en-US"/>
               <a:t>Click to edit Master title style</a:t>
             </a:r>
-            <a:endParaRPr lang="en-US"/>
           </a:p>
         </p:txBody>
       </p:sp>
@@ -2504,7 +2501,7 @@
           <a:p>
             <a:pPr lvl="0"/>
             <a:r>
-              <a:rPr lang="en-US" smtClean="0"/>
+              <a:rPr lang="en-US"/>
               <a:t>Click to edit Master text styles</a:t>
             </a:r>
           </a:p>
@@ -2527,7 +2524,7 @@
           <a:p>
             <a:fld id="{5BCAD085-E8A6-8845-BD4E-CB4CCA059FC4}" type="datetimeFigureOut">
               <a:rPr lang="en-US" smtClean="0"/>
-              <a:t>1/27/13</a:t>
+              <a:t>5/4/2026</a:t>
             </a:fld>
             <a:endParaRPr lang="en-US"/>
           </a:p>
@@ -2569,7 +2566,7 @@
           <a:p>
             <a:fld id="{C1FF6DA9-008F-8B48-92A6-B652298478BF}" type="slidenum">
               <a:rPr lang="en-US" smtClean="0"/>
-              <a:t>‹#›</a:t>
+              <a:t>‹nº›</a:t>
             </a:fld>
             <a:endParaRPr lang="en-US"/>
           </a:p>
@@ -2636,10 +2633,9 @@
           <a:lstStyle/>
           <a:p>
             <a:r>
-              <a:rPr lang="en-US" smtClean="0"/>
+              <a:rPr lang="en-US"/>
               <a:t>Click to edit Master title style</a:t>
             </a:r>
-            <a:endParaRPr lang="en-US"/>
           </a:p>
         </p:txBody>
       </p:sp>
@@ -2670,38 +2666,37 @@
           <a:p>
             <a:pPr lvl="0"/>
             <a:r>
-              <a:rPr lang="en-US" smtClean="0"/>
+              <a:rPr lang="en-US"/>
               <a:t>Click to edit Master text styles</a:t>
             </a:r>
           </a:p>
           <a:p>
             <a:pPr lvl="1"/>
             <a:r>
-              <a:rPr lang="en-US" smtClean="0"/>
+              <a:rPr lang="en-US"/>
               <a:t>Second level</a:t>
             </a:r>
           </a:p>
           <a:p>
             <a:pPr lvl="2"/>
             <a:r>
-              <a:rPr lang="en-US" smtClean="0"/>
+              <a:rPr lang="en-US"/>
               <a:t>Third level</a:t>
             </a:r>
           </a:p>
           <a:p>
             <a:pPr lvl="3"/>
             <a:r>
-              <a:rPr lang="en-US" smtClean="0"/>
+              <a:rPr lang="en-US"/>
               <a:t>Fourth level</a:t>
             </a:r>
           </a:p>
           <a:p>
             <a:pPr lvl="4"/>
             <a:r>
-              <a:rPr lang="en-US" smtClean="0"/>
+              <a:rPr lang="en-US"/>
               <a:t>Fifth level</a:t>
             </a:r>
-            <a:endParaRPr lang="en-US"/>
           </a:p>
         </p:txBody>
       </p:sp>
@@ -2740,7 +2735,7 @@
           <a:p>
             <a:fld id="{5BCAD085-E8A6-8845-BD4E-CB4CCA059FC4}" type="datetimeFigureOut">
               <a:rPr lang="en-US" smtClean="0"/>
-              <a:t>1/27/13</a:t>
+              <a:t>5/4/2026</a:t>
             </a:fld>
             <a:endParaRPr lang="en-US"/>
           </a:p>
@@ -2818,7 +2813,7 @@
           <a:p>
             <a:fld id="{C1FF6DA9-008F-8B48-92A6-B652298478BF}" type="slidenum">
               <a:rPr lang="en-US" smtClean="0"/>
-              <a:t>‹#›</a:t>
+              <a:t>‹nº›</a:t>
             </a:fld>
             <a:endParaRPr lang="en-US"/>
           </a:p>
@@ -3099,7 +3094,7 @@
 </file>
 
 <file path=ppt/slides/slide1.xml><?xml version="1.0" encoding="utf-8"?>
-<p:sld xmlns:a="http://schemas.openxmlformats.org/drawingml/2006/main" xmlns:p="http://schemas.openxmlformats.org/presentationml/2006/main" xmlns:r="http://schemas.openxmlformats.org/officeDocument/2006/relationships">
+<p:sld xmlns:a="http://schemas.openxmlformats.org/drawingml/2006/main" xmlns:r="http://schemas.openxmlformats.org/officeDocument/2006/relationships" xmlns:p="http://schemas.openxmlformats.org/presentationml/2006/main">
   <p:cSld>
     <p:bg>
       <p:bgPr>
@@ -3115,7 +3110,14 @@
         <p:cNvGrpSpPr/>
         <p:nvPr/>
       </p:nvGrpSpPr>
-      <p:grpSpPr/>
+      <p:grpSpPr>
+        <a:xfrm>
+          <a:off x="0" y="0"/>
+          <a:ext cx="0" cy="0"/>
+          <a:chOff x="0" y="0"/>
+          <a:chExt cx="0" cy="0"/>
+        </a:xfrm>
+      </p:grpSpPr>
       <p:sp>
         <p:nvSpPr>
           <p:cNvPr id="2" name="Rectangle 1"/>
@@ -3156,6 +3158,7 @@
           <a:lstStyle/>
           <a:p>
             <a:pPr algn="ctr"/>
+            <a:endParaRPr/>
           </a:p>
         </p:txBody>
       </p:sp>
@@ -3223,6 +3226,7 @@
           <a:lstStyle/>
           <a:p>
             <a:pPr algn="ctr"/>
+            <a:endParaRPr/>
           </a:p>
         </p:txBody>
       </p:sp>
@@ -3268,6 +3272,7 @@
           <a:lstStyle/>
           <a:p>
             <a:pPr algn="ctr"/>
+            <a:endParaRPr/>
           </a:p>
         </p:txBody>
       </p:sp>
@@ -3381,6 +3386,7 @@
           <a:lstStyle/>
           <a:p>
             <a:pPr algn="ctr"/>
+            <a:endParaRPr/>
           </a:p>
         </p:txBody>
       </p:sp>
@@ -3569,7 +3575,7 @@
 </file>
 
 <file path=ppt/slides/slide10.xml><?xml version="1.0" encoding="utf-8"?>
-<p:sld xmlns:a="http://schemas.openxmlformats.org/drawingml/2006/main" xmlns:p="http://schemas.openxmlformats.org/presentationml/2006/main" xmlns:r="http://schemas.openxmlformats.org/officeDocument/2006/relationships">
+<p:sld xmlns:a="http://schemas.openxmlformats.org/drawingml/2006/main" xmlns:r="http://schemas.openxmlformats.org/officeDocument/2006/relationships" xmlns:p="http://schemas.openxmlformats.org/presentationml/2006/main">
   <p:cSld>
     <p:bg>
       <p:bgPr>
@@ -3585,7 +3591,14 @@
         <p:cNvGrpSpPr/>
         <p:nvPr/>
       </p:nvGrpSpPr>
-      <p:grpSpPr/>
+      <p:grpSpPr>
+        <a:xfrm>
+          <a:off x="0" y="0"/>
+          <a:ext cx="0" cy="0"/>
+          <a:chOff x="0" y="0"/>
+          <a:chExt cx="0" cy="0"/>
+        </a:xfrm>
+      </p:grpSpPr>
       <p:sp>
         <p:nvSpPr>
           <p:cNvPr id="2" name="Rectangle 1"/>
@@ -3626,6 +3639,7 @@
           <a:lstStyle/>
           <a:p>
             <a:pPr algn="ctr"/>
+            <a:endParaRPr/>
           </a:p>
         </p:txBody>
       </p:sp>
@@ -3704,6 +3718,7 @@
           <a:lstStyle/>
           <a:p>
             <a:pPr algn="ctr"/>
+            <a:endParaRPr/>
           </a:p>
         </p:txBody>
       </p:sp>
@@ -3771,6 +3786,7 @@
           <a:lstStyle/>
           <a:p>
             <a:pPr algn="ctr"/>
+            <a:endParaRPr/>
           </a:p>
         </p:txBody>
       </p:sp>
@@ -3884,6 +3900,7 @@
           <a:lstStyle/>
           <a:p>
             <a:pPr algn="ctr"/>
+            <a:endParaRPr/>
           </a:p>
         </p:txBody>
       </p:sp>
@@ -3997,6 +4014,7 @@
           <a:lstStyle/>
           <a:p>
             <a:pPr algn="ctr"/>
+            <a:endParaRPr/>
           </a:p>
         </p:txBody>
       </p:sp>
@@ -4110,6 +4128,7 @@
           <a:lstStyle/>
           <a:p>
             <a:pPr algn="ctr"/>
+            <a:endParaRPr/>
           </a:p>
         </p:txBody>
       </p:sp>
@@ -4227,7 +4246,7 @@
 </file>
 
 <file path=ppt/slides/slide11.xml><?xml version="1.0" encoding="utf-8"?>
-<p:sld xmlns:a="http://schemas.openxmlformats.org/drawingml/2006/main" xmlns:p="http://schemas.openxmlformats.org/presentationml/2006/main" xmlns:r="http://schemas.openxmlformats.org/officeDocument/2006/relationships">
+<p:sld xmlns:a="http://schemas.openxmlformats.org/drawingml/2006/main" xmlns:r="http://schemas.openxmlformats.org/officeDocument/2006/relationships" xmlns:p="http://schemas.openxmlformats.org/presentationml/2006/main">
   <p:cSld>
     <p:bg>
       <p:bgPr>
@@ -4243,7 +4262,14 @@
         <p:cNvGrpSpPr/>
         <p:nvPr/>
       </p:nvGrpSpPr>
-      <p:grpSpPr/>
+      <p:grpSpPr>
+        <a:xfrm>
+          <a:off x="0" y="0"/>
+          <a:ext cx="0" cy="0"/>
+          <a:chOff x="0" y="0"/>
+          <a:chExt cx="0" cy="0"/>
+        </a:xfrm>
+      </p:grpSpPr>
       <p:sp>
         <p:nvSpPr>
           <p:cNvPr id="2" name="Rectangle 1"/>
@@ -4284,6 +4310,7 @@
           <a:lstStyle/>
           <a:p>
             <a:pPr algn="ctr"/>
+            <a:endParaRPr/>
           </a:p>
         </p:txBody>
       </p:sp>
@@ -4362,6 +4389,7 @@
           <a:lstStyle/>
           <a:p>
             <a:pPr algn="ctr"/>
+            <a:endParaRPr/>
           </a:p>
         </p:txBody>
       </p:sp>
@@ -4429,6 +4457,7 @@
           <a:lstStyle/>
           <a:p>
             <a:pPr algn="ctr"/>
+            <a:endParaRPr/>
           </a:p>
         </p:txBody>
       </p:sp>
@@ -4542,6 +4571,7 @@
           <a:lstStyle/>
           <a:p>
             <a:pPr algn="ctr"/>
+            <a:endParaRPr/>
           </a:p>
         </p:txBody>
       </p:sp>
@@ -4655,6 +4685,7 @@
           <a:lstStyle/>
           <a:p>
             <a:pPr algn="ctr"/>
+            <a:endParaRPr/>
           </a:p>
         </p:txBody>
       </p:sp>
@@ -4768,6 +4799,7 @@
           <a:lstStyle/>
           <a:p>
             <a:pPr algn="ctr"/>
+            <a:endParaRPr/>
           </a:p>
         </p:txBody>
       </p:sp>
@@ -4885,7 +4917,7 @@
 </file>
 
 <file path=ppt/slides/slide12.xml><?xml version="1.0" encoding="utf-8"?>
-<p:sld xmlns:a="http://schemas.openxmlformats.org/drawingml/2006/main" xmlns:p="http://schemas.openxmlformats.org/presentationml/2006/main" xmlns:r="http://schemas.openxmlformats.org/officeDocument/2006/relationships">
+<p:sld xmlns:a="http://schemas.openxmlformats.org/drawingml/2006/main" xmlns:r="http://schemas.openxmlformats.org/officeDocument/2006/relationships" xmlns:p="http://schemas.openxmlformats.org/presentationml/2006/main">
   <p:cSld>
     <p:bg>
       <p:bgPr>
@@ -4901,7 +4933,14 @@
         <p:cNvGrpSpPr/>
         <p:nvPr/>
       </p:nvGrpSpPr>
-      <p:grpSpPr/>
+      <p:grpSpPr>
+        <a:xfrm>
+          <a:off x="0" y="0"/>
+          <a:ext cx="0" cy="0"/>
+          <a:chOff x="0" y="0"/>
+          <a:chExt cx="0" cy="0"/>
+        </a:xfrm>
+      </p:grpSpPr>
       <p:sp>
         <p:nvSpPr>
           <p:cNvPr id="2" name="Rectangle 1"/>
@@ -4942,6 +4981,7 @@
           <a:lstStyle/>
           <a:p>
             <a:pPr algn="ctr"/>
+            <a:endParaRPr/>
           </a:p>
         </p:txBody>
       </p:sp>
@@ -5020,6 +5060,7 @@
           <a:lstStyle/>
           <a:p>
             <a:pPr algn="ctr"/>
+            <a:endParaRPr/>
           </a:p>
         </p:txBody>
       </p:sp>
@@ -5087,6 +5128,7 @@
           <a:lstStyle/>
           <a:p>
             <a:pPr algn="ctr"/>
+            <a:endParaRPr/>
           </a:p>
         </p:txBody>
       </p:sp>
@@ -5200,6 +5242,7 @@
           <a:lstStyle/>
           <a:p>
             <a:pPr algn="ctr"/>
+            <a:endParaRPr/>
           </a:p>
         </p:txBody>
       </p:sp>
@@ -5313,6 +5356,7 @@
           <a:lstStyle/>
           <a:p>
             <a:pPr algn="ctr"/>
+            <a:endParaRPr/>
           </a:p>
         </p:txBody>
       </p:sp>
@@ -5426,6 +5470,7 @@
           <a:lstStyle/>
           <a:p>
             <a:pPr algn="ctr"/>
+            <a:endParaRPr/>
           </a:p>
         </p:txBody>
       </p:sp>
@@ -5543,7 +5588,7 @@
 </file>
 
 <file path=ppt/slides/slide13.xml><?xml version="1.0" encoding="utf-8"?>
-<p:sld xmlns:a="http://schemas.openxmlformats.org/drawingml/2006/main" xmlns:p="http://schemas.openxmlformats.org/presentationml/2006/main" xmlns:r="http://schemas.openxmlformats.org/officeDocument/2006/relationships">
+<p:sld xmlns:a="http://schemas.openxmlformats.org/drawingml/2006/main" xmlns:r="http://schemas.openxmlformats.org/officeDocument/2006/relationships" xmlns:p="http://schemas.openxmlformats.org/presentationml/2006/main">
   <p:cSld>
     <p:bg>
       <p:bgPr>
@@ -5559,7 +5604,14 @@
         <p:cNvGrpSpPr/>
         <p:nvPr/>
       </p:nvGrpSpPr>
-      <p:grpSpPr/>
+      <p:grpSpPr>
+        <a:xfrm>
+          <a:off x="0" y="0"/>
+          <a:ext cx="0" cy="0"/>
+          <a:chOff x="0" y="0"/>
+          <a:chExt cx="0" cy="0"/>
+        </a:xfrm>
+      </p:grpSpPr>
       <p:sp>
         <p:nvSpPr>
           <p:cNvPr id="2" name="Rectangle 1"/>
@@ -5600,6 +5652,7 @@
           <a:lstStyle/>
           <a:p>
             <a:pPr algn="ctr"/>
+            <a:endParaRPr/>
           </a:p>
         </p:txBody>
       </p:sp>
@@ -5678,6 +5731,7 @@
           <a:lstStyle/>
           <a:p>
             <a:pPr algn="ctr"/>
+            <a:endParaRPr/>
           </a:p>
         </p:txBody>
       </p:sp>
@@ -5745,6 +5799,7 @@
           <a:lstStyle/>
           <a:p>
             <a:pPr algn="ctr"/>
+            <a:endParaRPr/>
           </a:p>
         </p:txBody>
       </p:sp>
@@ -5858,6 +5913,7 @@
           <a:lstStyle/>
           <a:p>
             <a:pPr algn="ctr"/>
+            <a:endParaRPr/>
           </a:p>
         </p:txBody>
       </p:sp>
@@ -5971,6 +6027,7 @@
           <a:lstStyle/>
           <a:p>
             <a:pPr algn="ctr"/>
+            <a:endParaRPr/>
           </a:p>
         </p:txBody>
       </p:sp>
@@ -6084,6 +6141,7 @@
           <a:lstStyle/>
           <a:p>
             <a:pPr algn="ctr"/>
+            <a:endParaRPr/>
           </a:p>
         </p:txBody>
       </p:sp>
@@ -6201,7 +6259,7 @@
 </file>
 
 <file path=ppt/slides/slide14.xml><?xml version="1.0" encoding="utf-8"?>
-<p:sld xmlns:a="http://schemas.openxmlformats.org/drawingml/2006/main" xmlns:p="http://schemas.openxmlformats.org/presentationml/2006/main" xmlns:r="http://schemas.openxmlformats.org/officeDocument/2006/relationships">
+<p:sld xmlns:a="http://schemas.openxmlformats.org/drawingml/2006/main" xmlns:r="http://schemas.openxmlformats.org/officeDocument/2006/relationships" xmlns:p="http://schemas.openxmlformats.org/presentationml/2006/main">
   <p:cSld>
     <p:bg>
       <p:bgPr>
@@ -6217,7 +6275,14 @@
         <p:cNvGrpSpPr/>
         <p:nvPr/>
       </p:nvGrpSpPr>
-      <p:grpSpPr/>
+      <p:grpSpPr>
+        <a:xfrm>
+          <a:off x="0" y="0"/>
+          <a:ext cx="0" cy="0"/>
+          <a:chOff x="0" y="0"/>
+          <a:chExt cx="0" cy="0"/>
+        </a:xfrm>
+      </p:grpSpPr>
       <p:sp>
         <p:nvSpPr>
           <p:cNvPr id="2" name="Rectangle 1"/>
@@ -6258,6 +6323,7 @@
           <a:lstStyle/>
           <a:p>
             <a:pPr algn="ctr"/>
+            <a:endParaRPr/>
           </a:p>
         </p:txBody>
       </p:sp>
@@ -6336,6 +6402,7 @@
           <a:lstStyle/>
           <a:p>
             <a:pPr algn="ctr"/>
+            <a:endParaRPr/>
           </a:p>
         </p:txBody>
       </p:sp>
@@ -6403,6 +6470,7 @@
           <a:lstStyle/>
           <a:p>
             <a:pPr algn="ctr"/>
+            <a:endParaRPr/>
           </a:p>
         </p:txBody>
       </p:sp>
@@ -6516,6 +6584,7 @@
           <a:lstStyle/>
           <a:p>
             <a:pPr algn="ctr"/>
+            <a:endParaRPr/>
           </a:p>
         </p:txBody>
       </p:sp>
@@ -6629,6 +6698,7 @@
           <a:lstStyle/>
           <a:p>
             <a:pPr algn="ctr"/>
+            <a:endParaRPr/>
           </a:p>
         </p:txBody>
       </p:sp>
@@ -6742,6 +6812,7 @@
           <a:lstStyle/>
           <a:p>
             <a:pPr algn="ctr"/>
+            <a:endParaRPr/>
           </a:p>
         </p:txBody>
       </p:sp>
@@ -6859,7 +6930,7 @@
 </file>
 
 <file path=ppt/slides/slide15.xml><?xml version="1.0" encoding="utf-8"?>
-<p:sld xmlns:a="http://schemas.openxmlformats.org/drawingml/2006/main" xmlns:p="http://schemas.openxmlformats.org/presentationml/2006/main" xmlns:r="http://schemas.openxmlformats.org/officeDocument/2006/relationships">
+<p:sld xmlns:a="http://schemas.openxmlformats.org/drawingml/2006/main" xmlns:r="http://schemas.openxmlformats.org/officeDocument/2006/relationships" xmlns:p="http://schemas.openxmlformats.org/presentationml/2006/main">
   <p:cSld>
     <p:bg>
       <p:bgPr>
@@ -6875,7 +6946,14 @@
         <p:cNvGrpSpPr/>
         <p:nvPr/>
       </p:nvGrpSpPr>
-      <p:grpSpPr/>
+      <p:grpSpPr>
+        <a:xfrm>
+          <a:off x="0" y="0"/>
+          <a:ext cx="0" cy="0"/>
+          <a:chOff x="0" y="0"/>
+          <a:chExt cx="0" cy="0"/>
+        </a:xfrm>
+      </p:grpSpPr>
       <p:sp>
         <p:nvSpPr>
           <p:cNvPr id="2" name="Rectangle 1"/>
@@ -6916,6 +6994,7 @@
           <a:lstStyle/>
           <a:p>
             <a:pPr algn="ctr"/>
+            <a:endParaRPr/>
           </a:p>
         </p:txBody>
       </p:sp>
@@ -6994,6 +7073,7 @@
           <a:lstStyle/>
           <a:p>
             <a:pPr algn="ctr"/>
+            <a:endParaRPr/>
           </a:p>
         </p:txBody>
       </p:sp>
@@ -7061,6 +7141,7 @@
           <a:lstStyle/>
           <a:p>
             <a:pPr algn="ctr"/>
+            <a:endParaRPr/>
           </a:p>
         </p:txBody>
       </p:sp>
@@ -7174,6 +7255,7 @@
           <a:lstStyle/>
           <a:p>
             <a:pPr algn="ctr"/>
+            <a:endParaRPr/>
           </a:p>
         </p:txBody>
       </p:sp>
@@ -7287,6 +7369,7 @@
           <a:lstStyle/>
           <a:p>
             <a:pPr algn="ctr"/>
+            <a:endParaRPr/>
           </a:p>
         </p:txBody>
       </p:sp>
@@ -7400,6 +7483,7 @@
           <a:lstStyle/>
           <a:p>
             <a:pPr algn="ctr"/>
+            <a:endParaRPr/>
           </a:p>
         </p:txBody>
       </p:sp>
@@ -7517,7 +7601,7 @@
 </file>
 
 <file path=ppt/slides/slide16.xml><?xml version="1.0" encoding="utf-8"?>
-<p:sld xmlns:a="http://schemas.openxmlformats.org/drawingml/2006/main" xmlns:p="http://schemas.openxmlformats.org/presentationml/2006/main" xmlns:r="http://schemas.openxmlformats.org/officeDocument/2006/relationships">
+<p:sld xmlns:a="http://schemas.openxmlformats.org/drawingml/2006/main" xmlns:r="http://schemas.openxmlformats.org/officeDocument/2006/relationships" xmlns:p="http://schemas.openxmlformats.org/presentationml/2006/main">
   <p:cSld>
     <p:bg>
       <p:bgPr>
@@ -7533,7 +7617,14 @@
         <p:cNvGrpSpPr/>
         <p:nvPr/>
       </p:nvGrpSpPr>
-      <p:grpSpPr/>
+      <p:grpSpPr>
+        <a:xfrm>
+          <a:off x="0" y="0"/>
+          <a:ext cx="0" cy="0"/>
+          <a:chOff x="0" y="0"/>
+          <a:chExt cx="0" cy="0"/>
+        </a:xfrm>
+      </p:grpSpPr>
       <p:sp>
         <p:nvSpPr>
           <p:cNvPr id="2" name="Rectangle 1"/>
@@ -7574,6 +7665,7 @@
           <a:lstStyle/>
           <a:p>
             <a:pPr algn="ctr"/>
+            <a:endParaRPr/>
           </a:p>
         </p:txBody>
       </p:sp>
@@ -7652,6 +7744,7 @@
           <a:lstStyle/>
           <a:p>
             <a:pPr algn="ctr"/>
+            <a:endParaRPr/>
           </a:p>
         </p:txBody>
       </p:sp>
@@ -7719,6 +7812,7 @@
           <a:lstStyle/>
           <a:p>
             <a:pPr algn="ctr"/>
+            <a:endParaRPr/>
           </a:p>
         </p:txBody>
       </p:sp>
@@ -7832,6 +7926,7 @@
           <a:lstStyle/>
           <a:p>
             <a:pPr algn="ctr"/>
+            <a:endParaRPr/>
           </a:p>
         </p:txBody>
       </p:sp>
@@ -7945,6 +8040,7 @@
           <a:lstStyle/>
           <a:p>
             <a:pPr algn="ctr"/>
+            <a:endParaRPr/>
           </a:p>
         </p:txBody>
       </p:sp>
@@ -8058,6 +8154,7 @@
           <a:lstStyle/>
           <a:p>
             <a:pPr algn="ctr"/>
+            <a:endParaRPr/>
           </a:p>
         </p:txBody>
       </p:sp>
@@ -8175,7 +8272,7 @@
 </file>
 
 <file path=ppt/slides/slide17.xml><?xml version="1.0" encoding="utf-8"?>
-<p:sld xmlns:a="http://schemas.openxmlformats.org/drawingml/2006/main" xmlns:p="http://schemas.openxmlformats.org/presentationml/2006/main" xmlns:r="http://schemas.openxmlformats.org/officeDocument/2006/relationships">
+<p:sld xmlns:a="http://schemas.openxmlformats.org/drawingml/2006/main" xmlns:r="http://schemas.openxmlformats.org/officeDocument/2006/relationships" xmlns:p="http://schemas.openxmlformats.org/presentationml/2006/main">
   <p:cSld>
     <p:bg>
       <p:bgPr>
@@ -8191,7 +8288,14 @@
         <p:cNvGrpSpPr/>
         <p:nvPr/>
       </p:nvGrpSpPr>
-      <p:grpSpPr/>
+      <p:grpSpPr>
+        <a:xfrm>
+          <a:off x="0" y="0"/>
+          <a:ext cx="0" cy="0"/>
+          <a:chOff x="0" y="0"/>
+          <a:chExt cx="0" cy="0"/>
+        </a:xfrm>
+      </p:grpSpPr>
       <p:sp>
         <p:nvSpPr>
           <p:cNvPr id="2" name="Rectangle 1"/>
@@ -8232,6 +8336,7 @@
           <a:lstStyle/>
           <a:p>
             <a:pPr algn="ctr"/>
+            <a:endParaRPr/>
           </a:p>
         </p:txBody>
       </p:sp>
@@ -8310,6 +8415,7 @@
           <a:lstStyle/>
           <a:p>
             <a:pPr algn="ctr"/>
+            <a:endParaRPr/>
           </a:p>
         </p:txBody>
       </p:sp>
@@ -8377,6 +8483,7 @@
           <a:lstStyle/>
           <a:p>
             <a:pPr algn="ctr"/>
+            <a:endParaRPr/>
           </a:p>
         </p:txBody>
       </p:sp>
@@ -8490,6 +8597,7 @@
           <a:lstStyle/>
           <a:p>
             <a:pPr algn="ctr"/>
+            <a:endParaRPr/>
           </a:p>
         </p:txBody>
       </p:sp>
@@ -8603,6 +8711,7 @@
           <a:lstStyle/>
           <a:p>
             <a:pPr algn="ctr"/>
+            <a:endParaRPr/>
           </a:p>
         </p:txBody>
       </p:sp>
@@ -8716,6 +8825,7 @@
           <a:lstStyle/>
           <a:p>
             <a:pPr algn="ctr"/>
+            <a:endParaRPr/>
           </a:p>
         </p:txBody>
       </p:sp>
@@ -8833,7 +8943,7 @@
 </file>
 
 <file path=ppt/slides/slide18.xml><?xml version="1.0" encoding="utf-8"?>
-<p:sld xmlns:a="http://schemas.openxmlformats.org/drawingml/2006/main" xmlns:p="http://schemas.openxmlformats.org/presentationml/2006/main" xmlns:r="http://schemas.openxmlformats.org/officeDocument/2006/relationships">
+<p:sld xmlns:a="http://schemas.openxmlformats.org/drawingml/2006/main" xmlns:r="http://schemas.openxmlformats.org/officeDocument/2006/relationships" xmlns:p="http://schemas.openxmlformats.org/presentationml/2006/main">
   <p:cSld>
     <p:bg>
       <p:bgPr>
@@ -8849,7 +8959,14 @@
         <p:cNvGrpSpPr/>
         <p:nvPr/>
       </p:nvGrpSpPr>
-      <p:grpSpPr/>
+      <p:grpSpPr>
+        <a:xfrm>
+          <a:off x="0" y="0"/>
+          <a:ext cx="0" cy="0"/>
+          <a:chOff x="0" y="0"/>
+          <a:chExt cx="0" cy="0"/>
+        </a:xfrm>
+      </p:grpSpPr>
       <p:sp>
         <p:nvSpPr>
           <p:cNvPr id="2" name="Rectangle 1"/>
@@ -8890,6 +9007,7 @@
           <a:lstStyle/>
           <a:p>
             <a:pPr algn="ctr"/>
+            <a:endParaRPr/>
           </a:p>
         </p:txBody>
       </p:sp>
@@ -8968,6 +9086,7 @@
           <a:lstStyle/>
           <a:p>
             <a:pPr algn="ctr"/>
+            <a:endParaRPr/>
           </a:p>
         </p:txBody>
       </p:sp>
@@ -9035,6 +9154,7 @@
           <a:lstStyle/>
           <a:p>
             <a:pPr algn="ctr"/>
+            <a:endParaRPr/>
           </a:p>
         </p:txBody>
       </p:sp>
@@ -9148,6 +9268,7 @@
           <a:lstStyle/>
           <a:p>
             <a:pPr algn="ctr"/>
+            <a:endParaRPr/>
           </a:p>
         </p:txBody>
       </p:sp>
@@ -9261,6 +9382,7 @@
           <a:lstStyle/>
           <a:p>
             <a:pPr algn="ctr"/>
+            <a:endParaRPr/>
           </a:p>
         </p:txBody>
       </p:sp>
@@ -9374,6 +9496,7 @@
           <a:lstStyle/>
           <a:p>
             <a:pPr algn="ctr"/>
+            <a:endParaRPr/>
           </a:p>
         </p:txBody>
       </p:sp>
@@ -9491,7 +9614,7 @@
 </file>
 
 <file path=ppt/slides/slide19.xml><?xml version="1.0" encoding="utf-8"?>
-<p:sld xmlns:a="http://schemas.openxmlformats.org/drawingml/2006/main" xmlns:p="http://schemas.openxmlformats.org/presentationml/2006/main" xmlns:r="http://schemas.openxmlformats.org/officeDocument/2006/relationships">
+<p:sld xmlns:a="http://schemas.openxmlformats.org/drawingml/2006/main" xmlns:r="http://schemas.openxmlformats.org/officeDocument/2006/relationships" xmlns:p="http://schemas.openxmlformats.org/presentationml/2006/main">
   <p:cSld>
     <p:bg>
       <p:bgPr>
@@ -9507,7 +9630,14 @@
         <p:cNvGrpSpPr/>
         <p:nvPr/>
       </p:nvGrpSpPr>
-      <p:grpSpPr/>
+      <p:grpSpPr>
+        <a:xfrm>
+          <a:off x="0" y="0"/>
+          <a:ext cx="0" cy="0"/>
+          <a:chOff x="0" y="0"/>
+          <a:chExt cx="0" cy="0"/>
+        </a:xfrm>
+      </p:grpSpPr>
       <p:sp>
         <p:nvSpPr>
           <p:cNvPr id="2" name="Rectangle 1"/>
@@ -9548,6 +9678,7 @@
           <a:lstStyle/>
           <a:p>
             <a:pPr algn="ctr"/>
+            <a:endParaRPr/>
           </a:p>
         </p:txBody>
       </p:sp>
@@ -9626,6 +9757,7 @@
           <a:lstStyle/>
           <a:p>
             <a:pPr algn="ctr"/>
+            <a:endParaRPr/>
           </a:p>
         </p:txBody>
       </p:sp>
@@ -9669,6 +9801,7 @@
           <a:lstStyle/>
           <a:p>
             <a:pPr algn="ctr"/>
+            <a:endParaRPr/>
           </a:p>
         </p:txBody>
       </p:sp>
@@ -9712,6 +9845,7 @@
           <a:lstStyle/>
           <a:p>
             <a:pPr algn="ctr"/>
+            <a:endParaRPr/>
           </a:p>
         </p:txBody>
       </p:sp>
@@ -9825,6 +9959,7 @@
           <a:lstStyle/>
           <a:p>
             <a:pPr algn="ctr"/>
+            <a:endParaRPr/>
           </a:p>
         </p:txBody>
       </p:sp>
@@ -9868,6 +10003,7 @@
           <a:lstStyle/>
           <a:p>
             <a:pPr algn="ctr"/>
+            <a:endParaRPr/>
           </a:p>
         </p:txBody>
       </p:sp>
@@ -9981,6 +10117,7 @@
           <a:lstStyle/>
           <a:p>
             <a:pPr algn="ctr"/>
+            <a:endParaRPr/>
           </a:p>
         </p:txBody>
       </p:sp>
@@ -10024,6 +10161,7 @@
           <a:lstStyle/>
           <a:p>
             <a:pPr algn="ctr"/>
+            <a:endParaRPr/>
           </a:p>
         </p:txBody>
       </p:sp>
@@ -10141,7 +10279,7 @@
 </file>
 
 <file path=ppt/slides/slide2.xml><?xml version="1.0" encoding="utf-8"?>
-<p:sld xmlns:a="http://schemas.openxmlformats.org/drawingml/2006/main" xmlns:p="http://schemas.openxmlformats.org/presentationml/2006/main" xmlns:r="http://schemas.openxmlformats.org/officeDocument/2006/relationships">
+<p:sld xmlns:a="http://schemas.openxmlformats.org/drawingml/2006/main" xmlns:r="http://schemas.openxmlformats.org/officeDocument/2006/relationships" xmlns:p="http://schemas.openxmlformats.org/presentationml/2006/main">
   <p:cSld>
     <p:bg>
       <p:bgPr>
@@ -10157,7 +10295,14 @@
         <p:cNvGrpSpPr/>
         <p:nvPr/>
       </p:nvGrpSpPr>
-      <p:grpSpPr/>
+      <p:grpSpPr>
+        <a:xfrm>
+          <a:off x="0" y="0"/>
+          <a:ext cx="0" cy="0"/>
+          <a:chOff x="0" y="0"/>
+          <a:chExt cx="0" cy="0"/>
+        </a:xfrm>
+      </p:grpSpPr>
       <p:sp>
         <p:nvSpPr>
           <p:cNvPr id="2" name="Rectangle 1"/>
@@ -10198,6 +10343,7 @@
           <a:lstStyle/>
           <a:p>
             <a:pPr algn="ctr"/>
+            <a:endParaRPr/>
           </a:p>
         </p:txBody>
       </p:sp>
@@ -10276,6 +10422,7 @@
           <a:lstStyle/>
           <a:p>
             <a:pPr algn="ctr"/>
+            <a:endParaRPr/>
           </a:p>
         </p:txBody>
       </p:sp>
@@ -10343,6 +10490,7 @@
           <a:lstStyle/>
           <a:p>
             <a:pPr algn="ctr"/>
+            <a:endParaRPr/>
           </a:p>
         </p:txBody>
       </p:sp>
@@ -10388,6 +10536,7 @@
           <a:lstStyle/>
           <a:p>
             <a:pPr algn="ctr"/>
+            <a:endParaRPr/>
           </a:p>
         </p:txBody>
       </p:sp>
@@ -10466,6 +10615,7 @@
           <a:lstStyle/>
           <a:p>
             <a:pPr algn="ctr"/>
+            <a:endParaRPr/>
           </a:p>
         </p:txBody>
       </p:sp>
@@ -10509,6 +10659,7 @@
           <a:lstStyle/>
           <a:p>
             <a:pPr algn="ctr"/>
+            <a:endParaRPr/>
           </a:p>
         </p:txBody>
       </p:sp>
@@ -10622,6 +10773,7 @@
           <a:lstStyle/>
           <a:p>
             <a:pPr algn="ctr"/>
+            <a:endParaRPr/>
           </a:p>
         </p:txBody>
       </p:sp>
@@ -10735,6 +10887,7 @@
           <a:lstStyle/>
           <a:p>
             <a:pPr algn="ctr"/>
+            <a:endParaRPr/>
           </a:p>
         </p:txBody>
       </p:sp>
@@ -10813,6 +10966,7 @@
           <a:lstStyle/>
           <a:p>
             <a:pPr algn="ctr"/>
+            <a:endParaRPr/>
           </a:p>
         </p:txBody>
       </p:sp>
@@ -10919,7 +11073,7 @@
 </file>
 
 <file path=ppt/slides/slide20.xml><?xml version="1.0" encoding="utf-8"?>
-<p:sld xmlns:a="http://schemas.openxmlformats.org/drawingml/2006/main" xmlns:p="http://schemas.openxmlformats.org/presentationml/2006/main" xmlns:r="http://schemas.openxmlformats.org/officeDocument/2006/relationships">
+<p:sld xmlns:a="http://schemas.openxmlformats.org/drawingml/2006/main" xmlns:r="http://schemas.openxmlformats.org/officeDocument/2006/relationships" xmlns:p="http://schemas.openxmlformats.org/presentationml/2006/main">
   <p:cSld>
     <p:bg>
       <p:bgPr>
@@ -10935,7 +11089,14 @@
         <p:cNvGrpSpPr/>
         <p:nvPr/>
       </p:nvGrpSpPr>
-      <p:grpSpPr/>
+      <p:grpSpPr>
+        <a:xfrm>
+          <a:off x="0" y="0"/>
+          <a:ext cx="0" cy="0"/>
+          <a:chOff x="0" y="0"/>
+          <a:chExt cx="0" cy="0"/>
+        </a:xfrm>
+      </p:grpSpPr>
       <p:sp>
         <p:nvSpPr>
           <p:cNvPr id="2" name="Rectangle 1"/>
@@ -10976,6 +11137,7 @@
           <a:lstStyle/>
           <a:p>
             <a:pPr algn="ctr"/>
+            <a:endParaRPr/>
           </a:p>
         </p:txBody>
       </p:sp>
@@ -11054,6 +11216,7 @@
           <a:lstStyle/>
           <a:p>
             <a:pPr algn="ctr"/>
+            <a:endParaRPr/>
           </a:p>
         </p:txBody>
       </p:sp>
@@ -11097,6 +11260,7 @@
           <a:lstStyle/>
           <a:p>
             <a:pPr algn="ctr"/>
+            <a:endParaRPr/>
           </a:p>
         </p:txBody>
       </p:sp>
@@ -11175,6 +11339,7 @@
           <a:lstStyle/>
           <a:p>
             <a:pPr algn="ctr"/>
+            <a:endParaRPr/>
           </a:p>
         </p:txBody>
       </p:sp>
@@ -11289,6 +11454,7 @@
           <a:lstStyle/>
           <a:p>
             <a:pPr algn="ctr"/>
+            <a:endParaRPr/>
           </a:p>
         </p:txBody>
       </p:sp>
@@ -11367,6 +11533,7 @@
           <a:lstStyle/>
           <a:p>
             <a:pPr algn="ctr"/>
+            <a:endParaRPr/>
           </a:p>
         </p:txBody>
       </p:sp>
@@ -11481,6 +11648,7 @@
           <a:lstStyle/>
           <a:p>
             <a:pPr algn="ctr"/>
+            <a:endParaRPr/>
           </a:p>
         </p:txBody>
       </p:sp>
@@ -11559,6 +11727,7 @@
           <a:lstStyle/>
           <a:p>
             <a:pPr algn="ctr"/>
+            <a:endParaRPr/>
           </a:p>
         </p:txBody>
       </p:sp>
@@ -11677,7 +11846,7 @@
 </file>
 
 <file path=ppt/slides/slide21.xml><?xml version="1.0" encoding="utf-8"?>
-<p:sld xmlns:a="http://schemas.openxmlformats.org/drawingml/2006/main" xmlns:p="http://schemas.openxmlformats.org/presentationml/2006/main" xmlns:r="http://schemas.openxmlformats.org/officeDocument/2006/relationships">
+<p:sld xmlns:a="http://schemas.openxmlformats.org/drawingml/2006/main" xmlns:r="http://schemas.openxmlformats.org/officeDocument/2006/relationships" xmlns:p="http://schemas.openxmlformats.org/presentationml/2006/main">
   <p:cSld>
     <p:bg>
       <p:bgPr>
@@ -11693,7 +11862,14 @@
         <p:cNvGrpSpPr/>
         <p:nvPr/>
       </p:nvGrpSpPr>
-      <p:grpSpPr/>
+      <p:grpSpPr>
+        <a:xfrm>
+          <a:off x="0" y="0"/>
+          <a:ext cx="0" cy="0"/>
+          <a:chOff x="0" y="0"/>
+          <a:chExt cx="0" cy="0"/>
+        </a:xfrm>
+      </p:grpSpPr>
       <p:sp>
         <p:nvSpPr>
           <p:cNvPr id="2" name="Rectangle 1"/>
@@ -11734,6 +11910,7 @@
           <a:lstStyle/>
           <a:p>
             <a:pPr algn="ctr"/>
+            <a:endParaRPr/>
           </a:p>
         </p:txBody>
       </p:sp>
@@ -11812,6 +11989,7 @@
           <a:lstStyle/>
           <a:p>
             <a:pPr algn="ctr"/>
+            <a:endParaRPr/>
           </a:p>
         </p:txBody>
       </p:sp>
@@ -11891,6 +12069,7 @@
           <a:lstStyle/>
           <a:p>
             <a:pPr algn="ctr"/>
+            <a:endParaRPr/>
           </a:p>
         </p:txBody>
       </p:sp>
@@ -12009,231 +12188,7 @@
 </file>
 
 <file path=ppt/slides/slide3.xml><?xml version="1.0" encoding="utf-8"?>
-<p:sld xmlns:a="http://schemas.openxmlformats.org/drawingml/2006/main" xmlns:p="http://schemas.openxmlformats.org/presentationml/2006/main" xmlns:r="http://schemas.openxmlformats.org/officeDocument/2006/relationships">
-  <p:cSld>
-    <p:bg>
-      <p:bgPr>
-        <a:solidFill>
-          <a:srgbClr val="1B274B"/>
-        </a:solidFill>
-        <a:effectLst/>
-      </p:bgPr>
-    </p:bg>
-    <p:spTree>
-      <p:sp>
-        <p:nvSpPr>
-          <p:cNvPr id="1" name="Rectangle 0"/>
-          <p:cNvSpPr/>
-          <p:nvPr/>
-        </p:nvSpPr>
-        <p:spPr>
-          <a:xfrm>
-            <a:off x="0" y="0"/>
-            <a:ext cx="228600" cy="10287000"/>
-          </a:xfrm>
-          <a:prstGeom prst="rect">
-            <a:avLst/>
-          </a:prstGeom>
-          <a:solidFill>
-            <a:srgbClr val="008B8B"/>
-          </a:solidFill>
-          <a:ln>
-            <a:noFill/>
-          </a:ln>
-        </p:spPr>
-        <p:style>
-          <a:lnRef idx="1">
-            <a:schemeClr val="accent1"/>
-          </a:lnRef>
-          <a:fillRef idx="3">
-            <a:schemeClr val="accent1"/>
-          </a:fillRef>
-          <a:effectRef idx="2">
-            <a:schemeClr val="accent1"/>
-          </a:effectRef>
-          <a:fontRef idx="minor">
-            <a:schemeClr val="lt1"/>
-          </a:fontRef>
-        </p:style>
-        <p:txBody>
-          <a:bodyPr rtlCol="0" anchor="ctr"/>
-          <a:lstStyle/>
-          <a:p>
-            <a:pPr algn="ctr"/>
-          </a:p>
-        </p:txBody>
-      </p:sp>
-      <p:sp>
-        <p:nvSpPr>
-          <p:cNvPr id="2" name="TextBox 1"/>
-          <p:cNvSpPr txBox="1"/>
-          <p:nvPr/>
-        </p:nvSpPr>
-        <p:spPr>
-          <a:xfrm>
-            <a:off x="502920" y="320040"/>
-            <a:ext cx="17190720" cy="777240"/>
-          </a:xfrm>
-          <a:prstGeom prst="rect">
-            <a:avLst/>
-          </a:prstGeom>
-          <a:noFill/>
-        </p:spPr>
-        <p:txBody>
-          <a:bodyPr wrap="square">
-            <a:spAutoFit/>
-          </a:bodyPr>
-          <a:lstStyle/>
-          <a:p>
-            <a:pPr algn="l"/>
-            <a:r>
-              <a:rPr sz="4200" b="1" i="0">
-                <a:solidFill>
-                  <a:srgbClr val="FFFFFF"/>
-                </a:solidFill>
-                <a:latin typeface="Calibri"/>
-              </a:rPr>
-              <a:t>Interface Gráfica</a:t>
-            </a:r>
-          </a:p>
-        </p:txBody>
-      </p:sp>
-      <p:sp>
-        <p:nvSpPr>
-          <p:cNvPr id="3" name="Rectangle 2"/>
-          <p:cNvSpPr/>
-          <p:nvPr/>
-        </p:nvSpPr>
-        <p:spPr>
-          <a:xfrm>
-            <a:off x="502920" y="1143000"/>
-            <a:ext cx="17282160" cy="25400"/>
-          </a:xfrm>
-          <a:prstGeom prst="rect">
-            <a:avLst/>
-          </a:prstGeom>
-          <a:solidFill>
-            <a:srgbClr val="008B8B"/>
-          </a:solidFill>
-          <a:ln>
-            <a:noFill/>
-          </a:ln>
-        </p:spPr>
-        <p:style>
-          <a:lnRef idx="1">
-            <a:schemeClr val="accent1"/>
-          </a:lnRef>
-          <a:fillRef idx="3">
-            <a:schemeClr val="accent1"/>
-          </a:fillRef>
-          <a:effectRef idx="2">
-            <a:schemeClr val="accent1"/>
-          </a:effectRef>
-          <a:fontRef idx="minor">
-            <a:schemeClr val="lt1"/>
-          </a:fontRef>
-        </p:style>
-        <p:txBody>
-          <a:bodyPr rtlCol="0" anchor="ctr"/>
-          <a:lstStyle/>
-          <a:p>
-            <a:pPr algn="ctr"/>
-          </a:p>
-        </p:txBody>
-      </p:sp>
-      <p:pic>
-        <p:nvPicPr>
-          <p:cNvPr id="4" name="Picture 3" descr="image6.png"/>
-          <p:cNvPicPr>
-            <a:picLocks noChangeAspect="1"/>
-          </p:cNvPicPr>
-          <p:nvPr/>
-        </p:nvPicPr>
-        <p:blipFill>
-          <a:blip r:embed="rId2"/>
-          <a:stretch>
-            <a:fillRect/>
-          </a:stretch>
-        </p:blipFill>
-        <p:spPr>
-          <a:xfrm>
-            <a:off x="548640" y="1371600"/>
-            <a:ext cx="7315200" cy="7955279"/>
-          </a:xfrm>
-          <a:prstGeom prst="rect">
-            <a:avLst/>
-          </a:prstGeom>
-        </p:spPr>
-      </p:pic>
-      <p:pic>
-        <p:nvPicPr>
-          <p:cNvPr id="5" name="Picture 4" descr="image7.png"/>
-          <p:cNvPicPr>
-            <a:picLocks noChangeAspect="1"/>
-          </p:cNvPicPr>
-          <p:nvPr/>
-        </p:nvPicPr>
-        <p:blipFill>
-          <a:blip r:embed="rId3"/>
-          <a:stretch>
-            <a:fillRect/>
-          </a:stretch>
-        </p:blipFill>
-        <p:spPr>
-          <a:xfrm>
-            <a:off x="8229600" y="1371600"/>
-            <a:ext cx="9784080" cy="6858000"/>
-          </a:xfrm>
-          <a:prstGeom prst="rect">
-            <a:avLst/>
-          </a:prstGeom>
-        </p:spPr>
-      </p:pic>
-      <p:sp>
-        <p:nvSpPr>
-          <p:cNvPr id="6" name="TextBox 5"/>
-          <p:cNvSpPr txBox="1"/>
-          <p:nvPr/>
-        </p:nvSpPr>
-        <p:spPr>
-          <a:xfrm>
-            <a:off x="16916400" y="9829800"/>
-            <a:ext cx="1097280" cy="320040"/>
-          </a:xfrm>
-          <a:prstGeom prst="rect">
-            <a:avLst/>
-          </a:prstGeom>
-          <a:noFill/>
-        </p:spPr>
-        <p:txBody>
-          <a:bodyPr wrap="square">
-            <a:spAutoFit/>
-          </a:bodyPr>
-          <a:lstStyle/>
-          <a:p>
-            <a:pPr algn="r"/>
-            <a:r>
-              <a:rPr sz="1000" b="0" i="0">
-                <a:solidFill>
-                  <a:srgbClr val="8090A0"/>
-                </a:solidFill>
-                <a:latin typeface="Calibri Light"/>
-              </a:rPr>
-              <a:t>3 / 21</a:t>
-            </a:r>
-          </a:p>
-        </p:txBody>
-      </p:sp>
-    </p:spTree>
-  </p:cSld>
-  <p:clrMapOvr>
-    <a:masterClrMapping/>
-  </p:clrMapOvr>
-</p:sld>
-</file>
-
-<file path=ppt/slides/slide4.xml><?xml version="1.0" encoding="utf-8"?>
-<p:sld xmlns:a="http://schemas.openxmlformats.org/drawingml/2006/main" xmlns:p="http://schemas.openxmlformats.org/presentationml/2006/main" xmlns:r="http://schemas.openxmlformats.org/officeDocument/2006/relationships">
+<p:sld xmlns:a="http://schemas.openxmlformats.org/drawingml/2006/main" xmlns:r="http://schemas.openxmlformats.org/officeDocument/2006/relationships" xmlns:p="http://schemas.openxmlformats.org/presentationml/2006/main">
   <p:cSld>
     <p:bg>
       <p:bgPr>
@@ -12249,10 +12204,17 @@
         <p:cNvGrpSpPr/>
         <p:nvPr/>
       </p:nvGrpSpPr>
-      <p:grpSpPr/>
-      <p:sp>
-        <p:nvSpPr>
-          <p:cNvPr id="2" name="Rectangle 1"/>
+      <p:grpSpPr>
+        <a:xfrm>
+          <a:off x="0" y="0"/>
+          <a:ext cx="0" cy="0"/>
+          <a:chOff x="0" y="0"/>
+          <a:chExt cx="0" cy="0"/>
+        </a:xfrm>
+      </p:grpSpPr>
+      <p:sp>
+        <p:nvSpPr>
+          <p:cNvPr id="7" name="Rectangle 0"/>
           <p:cNvSpPr/>
           <p:nvPr/>
         </p:nvSpPr>
@@ -12290,12 +12252,13 @@
           <a:lstStyle/>
           <a:p>
             <a:pPr algn="ctr"/>
-          </a:p>
-        </p:txBody>
-      </p:sp>
-      <p:sp>
-        <p:nvSpPr>
-          <p:cNvPr id="3" name="TextBox 2"/>
+            <a:endParaRPr/>
+          </a:p>
+        </p:txBody>
+      </p:sp>
+      <p:sp>
+        <p:nvSpPr>
+          <p:cNvPr id="2" name="TextBox 1"/>
           <p:cNvSpPr txBox="1"/>
           <p:nvPr/>
         </p:nvSpPr>
@@ -12323,14 +12286,14 @@
                 </a:solidFill>
                 <a:latin typeface="Calibri"/>
               </a:rPr>
-              <a:t>Comparação de Malhas</a:t>
-            </a:r>
-          </a:p>
-        </p:txBody>
-      </p:sp>
-      <p:sp>
-        <p:nvSpPr>
-          <p:cNvPr id="4" name="Rectangle 3"/>
+              <a:t>Interface Gráfica</a:t>
+            </a:r>
+          </a:p>
+        </p:txBody>
+      </p:sp>
+      <p:sp>
+        <p:nvSpPr>
+          <p:cNvPr id="3" name="Rectangle 2"/>
           <p:cNvSpPr/>
           <p:nvPr/>
         </p:nvSpPr>
@@ -12368,12 +12331,13 @@
           <a:lstStyle/>
           <a:p>
             <a:pPr algn="ctr"/>
+            <a:endParaRPr/>
           </a:p>
         </p:txBody>
       </p:sp>
       <p:pic>
         <p:nvPicPr>
-          <p:cNvPr id="5" name="Picture 4" descr="image8.png"/>
+          <p:cNvPr id="4" name="Picture 3" descr="image6.png"/>
           <p:cNvPicPr>
             <a:picLocks noChangeAspect="1"/>
           </p:cNvPicPr>
@@ -12388,7 +12352,7 @@
         <p:spPr>
           <a:xfrm>
             <a:off x="548640" y="1371600"/>
-            <a:ext cx="17373600" cy="8412480"/>
+            <a:ext cx="7315200" cy="7955279"/>
           </a:xfrm>
           <a:prstGeom prst="rect">
             <a:avLst/>
@@ -12425,11 +12389,41 @@
                 </a:solidFill>
                 <a:latin typeface="Calibri Light"/>
               </a:rPr>
-              <a:t>4 / 21</a:t>
-            </a:r>
-          </a:p>
-        </p:txBody>
-      </p:sp>
+              <a:t>3 / 21</a:t>
+            </a:r>
+          </a:p>
+        </p:txBody>
+      </p:sp>
+      <p:pic>
+        <p:nvPicPr>
+          <p:cNvPr id="9" name="Imagem 8">
+            <a:extLst>
+              <a:ext uri="{FF2B5EF4-FFF2-40B4-BE49-F238E27FC236}">
+                <a16:creationId xmlns:a16="http://schemas.microsoft.com/office/drawing/2014/main" id="{6CC398C4-8D43-4105-9F8E-6B51C9025D2A}"/>
+              </a:ext>
+            </a:extLst>
+          </p:cNvPr>
+          <p:cNvPicPr>
+            <a:picLocks noChangeAspect="1"/>
+          </p:cNvPicPr>
+          <p:nvPr/>
+        </p:nvPicPr>
+        <p:blipFill>
+          <a:blip r:embed="rId3"/>
+          <a:stretch>
+            <a:fillRect/>
+          </a:stretch>
+        </p:blipFill>
+        <p:spPr>
+          <a:xfrm>
+            <a:off x="8229599" y="1374438"/>
+            <a:ext cx="9753487" cy="6518986"/>
+          </a:xfrm>
+          <a:prstGeom prst="rect">
+            <a:avLst/>
+          </a:prstGeom>
+        </p:spPr>
+      </p:pic>
     </p:spTree>
   </p:cSld>
   <p:clrMapOvr>
@@ -12438,8 +12432,8 @@
 </p:sld>
 </file>
 
-<file path=ppt/slides/slide5.xml><?xml version="1.0" encoding="utf-8"?>
-<p:sld xmlns:a="http://schemas.openxmlformats.org/drawingml/2006/main" xmlns:p="http://schemas.openxmlformats.org/presentationml/2006/main" xmlns:r="http://schemas.openxmlformats.org/officeDocument/2006/relationships">
+<file path=ppt/slides/slide4.xml><?xml version="1.0" encoding="utf-8"?>
+<p:sld xmlns:a="http://schemas.openxmlformats.org/drawingml/2006/main" xmlns:r="http://schemas.openxmlformats.org/officeDocument/2006/relationships" xmlns:p="http://schemas.openxmlformats.org/presentationml/2006/main">
   <p:cSld>
     <p:bg>
       <p:bgPr>
@@ -12455,7 +12449,14 @@
         <p:cNvGrpSpPr/>
         <p:nvPr/>
       </p:nvGrpSpPr>
-      <p:grpSpPr/>
+      <p:grpSpPr>
+        <a:xfrm>
+          <a:off x="0" y="0"/>
+          <a:ext cx="0" cy="0"/>
+          <a:chOff x="0" y="0"/>
+          <a:chExt cx="0" cy="0"/>
+        </a:xfrm>
+      </p:grpSpPr>
       <p:sp>
         <p:nvSpPr>
           <p:cNvPr id="2" name="Rectangle 1"/>
@@ -12495,7 +12496,37 @@
           <a:bodyPr rtlCol="0" anchor="ctr"/>
           <a:lstStyle/>
           <a:p>
-            <a:pPr algn="ctr"/>
+            <a:pPr marL="0" marR="0" lvl="0" indent="0" algn="ctr" defTabSz="457200" rtl="0" eaLnBrk="1" fontAlgn="auto" latinLnBrk="0" hangingPunct="1">
+              <a:lnSpc>
+                <a:spcPct val="100000"/>
+              </a:lnSpc>
+              <a:spcBef>
+                <a:spcPts val="0"/>
+              </a:spcBef>
+              <a:spcAft>
+                <a:spcPts val="0"/>
+              </a:spcAft>
+              <a:buClrTx/>
+              <a:buSzTx/>
+              <a:buFontTx/>
+              <a:buNone/>
+              <a:tabLst/>
+              <a:defRPr/>
+            </a:pPr>
+            <a:endParaRPr kumimoji="0" sz="1800" b="0" i="0" u="none" strike="noStrike" kern="1200" cap="none" spc="0" normalizeH="0" baseline="0" noProof="0">
+              <a:ln>
+                <a:noFill/>
+              </a:ln>
+              <a:solidFill>
+                <a:prstClr val="white"/>
+              </a:solidFill>
+              <a:effectLst/>
+              <a:uLnTx/>
+              <a:uFillTx/>
+              <a:latin typeface="Calibri"/>
+              <a:ea typeface="+mn-ea"/>
+              <a:cs typeface="+mn-cs"/>
+            </a:endParaRPr>
           </a:p>
         </p:txBody>
       </p:sp>
@@ -12521,15 +12552,39 @@
           </a:bodyPr>
           <a:lstStyle/>
           <a:p>
-            <a:pPr algn="l"/>
-            <a:r>
-              <a:rPr sz="4200" b="1" i="0">
+            <a:pPr marL="0" marR="0" lvl="0" indent="0" algn="l" defTabSz="457200" rtl="0" eaLnBrk="1" fontAlgn="auto" latinLnBrk="0" hangingPunct="1">
+              <a:lnSpc>
+                <a:spcPct val="100000"/>
+              </a:lnSpc>
+              <a:spcBef>
+                <a:spcPts val="0"/>
+              </a:spcBef>
+              <a:spcAft>
+                <a:spcPts val="0"/>
+              </a:spcAft>
+              <a:buClrTx/>
+              <a:buSzTx/>
+              <a:buFontTx/>
+              <a:buNone/>
+              <a:tabLst/>
+              <a:defRPr/>
+            </a:pPr>
+            <a:r>
+              <a:rPr kumimoji="0" sz="4200" b="1" i="0" u="none" strike="noStrike" kern="1200" cap="none" spc="0" normalizeH="0" baseline="0" noProof="0">
+                <a:ln>
+                  <a:noFill/>
+                </a:ln>
                 <a:solidFill>
                   <a:srgbClr val="FFFFFF"/>
                 </a:solidFill>
+                <a:effectLst/>
+                <a:uLnTx/>
+                <a:uFillTx/>
                 <a:latin typeface="Calibri"/>
-              </a:rPr>
-              <a:t>Métodos de Identificação</a:t>
+                <a:ea typeface="+mn-ea"/>
+                <a:cs typeface="+mn-cs"/>
+              </a:rPr>
+              <a:t>Comparação de Malhas</a:t>
             </a:r>
           </a:p>
         </p:txBody>
@@ -12573,20 +12628,177 @@
           <a:bodyPr rtlCol="0" anchor="ctr"/>
           <a:lstStyle/>
           <a:p>
-            <a:pPr algn="ctr"/>
-          </a:p>
-        </p:txBody>
-      </p:sp>
-      <p:sp>
-        <p:nvSpPr>
-          <p:cNvPr id="5" name="Rectangle 4"/>
+            <a:pPr marL="0" marR="0" lvl="0" indent="0" algn="ctr" defTabSz="457200" rtl="0" eaLnBrk="1" fontAlgn="auto" latinLnBrk="0" hangingPunct="1">
+              <a:lnSpc>
+                <a:spcPct val="100000"/>
+              </a:lnSpc>
+              <a:spcBef>
+                <a:spcPts val="0"/>
+              </a:spcBef>
+              <a:spcAft>
+                <a:spcPts val="0"/>
+              </a:spcAft>
+              <a:buClrTx/>
+              <a:buSzTx/>
+              <a:buFontTx/>
+              <a:buNone/>
+              <a:tabLst/>
+              <a:defRPr/>
+            </a:pPr>
+            <a:endParaRPr kumimoji="0" sz="1800" b="0" i="0" u="none" strike="noStrike" kern="1200" cap="none" spc="0" normalizeH="0" baseline="0" noProof="0">
+              <a:ln>
+                <a:noFill/>
+              </a:ln>
+              <a:solidFill>
+                <a:prstClr val="white"/>
+              </a:solidFill>
+              <a:effectLst/>
+              <a:uLnTx/>
+              <a:uFillTx/>
+              <a:latin typeface="Calibri"/>
+              <a:ea typeface="+mn-ea"/>
+              <a:cs typeface="+mn-cs"/>
+            </a:endParaRPr>
+          </a:p>
+        </p:txBody>
+      </p:sp>
+      <p:sp>
+        <p:nvSpPr>
+          <p:cNvPr id="6" name="TextBox 5"/>
+          <p:cNvSpPr txBox="1"/>
+          <p:nvPr/>
+        </p:nvSpPr>
+        <p:spPr>
+          <a:xfrm>
+            <a:off x="16916400" y="9829800"/>
+            <a:ext cx="1097280" cy="320040"/>
+          </a:xfrm>
+          <a:prstGeom prst="rect">
+            <a:avLst/>
+          </a:prstGeom>
+          <a:noFill/>
+        </p:spPr>
+        <p:txBody>
+          <a:bodyPr wrap="square">
+            <a:spAutoFit/>
+          </a:bodyPr>
+          <a:lstStyle/>
+          <a:p>
+            <a:pPr marL="0" marR="0" lvl="0" indent="0" algn="r" defTabSz="457200" rtl="0" eaLnBrk="1" fontAlgn="auto" latinLnBrk="0" hangingPunct="1">
+              <a:lnSpc>
+                <a:spcPct val="100000"/>
+              </a:lnSpc>
+              <a:spcBef>
+                <a:spcPts val="0"/>
+              </a:spcBef>
+              <a:spcAft>
+                <a:spcPts val="0"/>
+              </a:spcAft>
+              <a:buClrTx/>
+              <a:buSzTx/>
+              <a:buFontTx/>
+              <a:buNone/>
+              <a:tabLst/>
+              <a:defRPr/>
+            </a:pPr>
+            <a:r>
+              <a:rPr kumimoji="0" sz="1000" b="0" i="0" u="none" strike="noStrike" kern="1200" cap="none" spc="0" normalizeH="0" baseline="0" noProof="0">
+                <a:ln>
+                  <a:noFill/>
+                </a:ln>
+                <a:solidFill>
+                  <a:srgbClr val="8090A0"/>
+                </a:solidFill>
+                <a:effectLst/>
+                <a:uLnTx/>
+                <a:uFillTx/>
+                <a:latin typeface="Calibri Light"/>
+                <a:ea typeface="+mn-ea"/>
+                <a:cs typeface="+mn-cs"/>
+              </a:rPr>
+              <a:t>4 / 21</a:t>
+            </a:r>
+          </a:p>
+        </p:txBody>
+      </p:sp>
+      <p:pic>
+        <p:nvPicPr>
+          <p:cNvPr id="8" name="Imagem 7">
+            <a:extLst>
+              <a:ext uri="{FF2B5EF4-FFF2-40B4-BE49-F238E27FC236}">
+                <a16:creationId xmlns:a16="http://schemas.microsoft.com/office/drawing/2014/main" id="{ADFAD829-6AF9-4E9D-9D30-025DCC59C75C}"/>
+              </a:ext>
+            </a:extLst>
+          </p:cNvPr>
+          <p:cNvPicPr>
+            <a:picLocks noChangeAspect="1"/>
+          </p:cNvPicPr>
+          <p:nvPr/>
+        </p:nvPicPr>
+        <p:blipFill>
+          <a:blip r:embed="rId2"/>
+          <a:stretch>
+            <a:fillRect/>
+          </a:stretch>
+        </p:blipFill>
+        <p:spPr>
+          <a:xfrm>
+            <a:off x="580358" y="1340522"/>
+            <a:ext cx="17127283" cy="8413200"/>
+          </a:xfrm>
+          <a:prstGeom prst="rect">
+            <a:avLst/>
+          </a:prstGeom>
+        </p:spPr>
+      </p:pic>
+    </p:spTree>
+    <p:extLst>
+      <p:ext uri="{BB962C8B-B14F-4D97-AF65-F5344CB8AC3E}">
+        <p14:creationId xmlns:p14="http://schemas.microsoft.com/office/powerpoint/2010/main" val="1522112424"/>
+      </p:ext>
+    </p:extLst>
+  </p:cSld>
+  <p:clrMapOvr>
+    <a:masterClrMapping/>
+  </p:clrMapOvr>
+</p:sld>
+</file>
+
+<file path=ppt/slides/slide5.xml><?xml version="1.0" encoding="utf-8"?>
+<p:sld xmlns:a="http://schemas.openxmlformats.org/drawingml/2006/main" xmlns:r="http://schemas.openxmlformats.org/officeDocument/2006/relationships" xmlns:p="http://schemas.openxmlformats.org/presentationml/2006/main">
+  <p:cSld>
+    <p:bg>
+      <p:bgPr>
+        <a:solidFill>
+          <a:srgbClr val="1B274B"/>
+        </a:solidFill>
+        <a:effectLst/>
+      </p:bgPr>
+    </p:bg>
+    <p:spTree>
+      <p:nvGrpSpPr>
+        <p:cNvPr id="1" name=""/>
+        <p:cNvGrpSpPr/>
+        <p:nvPr/>
+      </p:nvGrpSpPr>
+      <p:grpSpPr>
+        <a:xfrm>
+          <a:off x="0" y="0"/>
+          <a:ext cx="0" cy="0"/>
+          <a:chOff x="0" y="0"/>
+          <a:chExt cx="0" cy="0"/>
+        </a:xfrm>
+      </p:grpSpPr>
+      <p:sp>
+        <p:nvSpPr>
+          <p:cNvPr id="2" name="Rectangle 1"/>
           <p:cNvSpPr/>
           <p:nvPr/>
         </p:nvSpPr>
         <p:spPr>
           <a:xfrm>
-            <a:off x="548640" y="1371600"/>
-            <a:ext cx="8595360" cy="594360"/>
+            <a:off x="0" y="0"/>
+            <a:ext cx="228600" cy="10287000"/>
           </a:xfrm>
           <a:prstGeom prst="rect">
             <a:avLst/>
@@ -12617,6 +12829,130 @@
           <a:lstStyle/>
           <a:p>
             <a:pPr algn="ctr"/>
+            <a:endParaRPr/>
+          </a:p>
+        </p:txBody>
+      </p:sp>
+      <p:sp>
+        <p:nvSpPr>
+          <p:cNvPr id="3" name="TextBox 2"/>
+          <p:cNvSpPr txBox="1"/>
+          <p:nvPr/>
+        </p:nvSpPr>
+        <p:spPr>
+          <a:xfrm>
+            <a:off x="502920" y="320040"/>
+            <a:ext cx="17190720" cy="777240"/>
+          </a:xfrm>
+          <a:prstGeom prst="rect">
+            <a:avLst/>
+          </a:prstGeom>
+          <a:noFill/>
+        </p:spPr>
+        <p:txBody>
+          <a:bodyPr wrap="square">
+            <a:spAutoFit/>
+          </a:bodyPr>
+          <a:lstStyle/>
+          <a:p>
+            <a:pPr algn="l"/>
+            <a:r>
+              <a:rPr sz="4200" b="1" i="0">
+                <a:solidFill>
+                  <a:srgbClr val="FFFFFF"/>
+                </a:solidFill>
+                <a:latin typeface="Calibri"/>
+              </a:rPr>
+              <a:t>Métodos de Identificação</a:t>
+            </a:r>
+          </a:p>
+        </p:txBody>
+      </p:sp>
+      <p:sp>
+        <p:nvSpPr>
+          <p:cNvPr id="4" name="Rectangle 3"/>
+          <p:cNvSpPr/>
+          <p:nvPr/>
+        </p:nvSpPr>
+        <p:spPr>
+          <a:xfrm>
+            <a:off x="502920" y="1143000"/>
+            <a:ext cx="17282160" cy="25400"/>
+          </a:xfrm>
+          <a:prstGeom prst="rect">
+            <a:avLst/>
+          </a:prstGeom>
+          <a:solidFill>
+            <a:srgbClr val="008B8B"/>
+          </a:solidFill>
+          <a:ln>
+            <a:noFill/>
+          </a:ln>
+        </p:spPr>
+        <p:style>
+          <a:lnRef idx="1">
+            <a:schemeClr val="accent1"/>
+          </a:lnRef>
+          <a:fillRef idx="3">
+            <a:schemeClr val="accent1"/>
+          </a:fillRef>
+          <a:effectRef idx="2">
+            <a:schemeClr val="accent1"/>
+          </a:effectRef>
+          <a:fontRef idx="minor">
+            <a:schemeClr val="lt1"/>
+          </a:fontRef>
+        </p:style>
+        <p:txBody>
+          <a:bodyPr rtlCol="0" anchor="ctr"/>
+          <a:lstStyle/>
+          <a:p>
+            <a:pPr algn="ctr"/>
+            <a:endParaRPr/>
+          </a:p>
+        </p:txBody>
+      </p:sp>
+      <p:sp>
+        <p:nvSpPr>
+          <p:cNvPr id="5" name="Rectangle 4"/>
+          <p:cNvSpPr/>
+          <p:nvPr/>
+        </p:nvSpPr>
+        <p:spPr>
+          <a:xfrm>
+            <a:off x="548640" y="1371600"/>
+            <a:ext cx="8595360" cy="594360"/>
+          </a:xfrm>
+          <a:prstGeom prst="rect">
+            <a:avLst/>
+          </a:prstGeom>
+          <a:solidFill>
+            <a:srgbClr val="008B8B"/>
+          </a:solidFill>
+          <a:ln>
+            <a:noFill/>
+          </a:ln>
+        </p:spPr>
+        <p:style>
+          <a:lnRef idx="1">
+            <a:schemeClr val="accent1"/>
+          </a:lnRef>
+          <a:fillRef idx="3">
+            <a:schemeClr val="accent1"/>
+          </a:fillRef>
+          <a:effectRef idx="2">
+            <a:schemeClr val="accent1"/>
+          </a:effectRef>
+          <a:fontRef idx="minor">
+            <a:schemeClr val="lt1"/>
+          </a:fontRef>
+        </p:style>
+        <p:txBody>
+          <a:bodyPr rtlCol="0" anchor="ctr"/>
+          <a:lstStyle/>
+          <a:p>
+            <a:pPr algn="ctr"/>
+            <a:endParaRPr/>
           </a:p>
         </p:txBody>
       </p:sp>
@@ -12695,6 +13031,7 @@
           <a:lstStyle/>
           <a:p>
             <a:pPr algn="ctr"/>
+            <a:endParaRPr/>
           </a:p>
         </p:txBody>
       </p:sp>
@@ -12825,7 +13162,7 @@
 </file>
 
 <file path=ppt/slides/slide6.xml><?xml version="1.0" encoding="utf-8"?>
-<p:sld xmlns:a="http://schemas.openxmlformats.org/drawingml/2006/main" xmlns:p="http://schemas.openxmlformats.org/presentationml/2006/main" xmlns:r="http://schemas.openxmlformats.org/officeDocument/2006/relationships">
+<p:sld xmlns:a="http://schemas.openxmlformats.org/drawingml/2006/main" xmlns:r="http://schemas.openxmlformats.org/officeDocument/2006/relationships" xmlns:p="http://schemas.openxmlformats.org/presentationml/2006/main">
   <p:cSld>
     <p:bg>
       <p:bgPr>
@@ -12841,7 +13178,14 @@
         <p:cNvGrpSpPr/>
         <p:nvPr/>
       </p:nvGrpSpPr>
-      <p:grpSpPr/>
+      <p:grpSpPr>
+        <a:xfrm>
+          <a:off x="0" y="0"/>
+          <a:ext cx="0" cy="0"/>
+          <a:chOff x="0" y="0"/>
+          <a:chExt cx="0" cy="0"/>
+        </a:xfrm>
+      </p:grpSpPr>
       <p:sp>
         <p:nvSpPr>
           <p:cNvPr id="2" name="Rectangle 1"/>
@@ -12882,6 +13226,7 @@
           <a:lstStyle/>
           <a:p>
             <a:pPr algn="ctr"/>
+            <a:endParaRPr/>
           </a:p>
         </p:txBody>
       </p:sp>
@@ -12960,12 +13305,510 @@
           <a:lstStyle/>
           <a:p>
             <a:pPr algn="ctr"/>
+            <a:endParaRPr/>
+          </a:p>
+        </p:txBody>
+      </p:sp>
+      <p:sp>
+        <p:nvSpPr>
+          <p:cNvPr id="6" name="Rectangle 5"/>
+          <p:cNvSpPr/>
+          <p:nvPr/>
+        </p:nvSpPr>
+        <p:spPr>
+          <a:xfrm>
+            <a:off x="10972800" y="1371600"/>
+            <a:ext cx="7132320" cy="1600200"/>
+          </a:xfrm>
+          <a:prstGeom prst="rect">
+            <a:avLst/>
+          </a:prstGeom>
+          <a:solidFill>
+            <a:srgbClr val="AAD6D4"/>
+          </a:solidFill>
+          <a:ln>
+            <a:noFill/>
+          </a:ln>
+        </p:spPr>
+        <p:style>
+          <a:lnRef idx="1">
+            <a:schemeClr val="accent1"/>
+          </a:lnRef>
+          <a:fillRef idx="3">
+            <a:schemeClr val="accent1"/>
+          </a:fillRef>
+          <a:effectRef idx="2">
+            <a:schemeClr val="accent1"/>
+          </a:effectRef>
+          <a:fontRef idx="minor">
+            <a:schemeClr val="lt1"/>
+          </a:fontRef>
+        </p:style>
+        <p:txBody>
+          <a:bodyPr rtlCol="0" anchor="ctr"/>
+          <a:lstStyle/>
+          <a:p>
+            <a:pPr algn="ctr"/>
+            <a:endParaRPr/>
+          </a:p>
+        </p:txBody>
+      </p:sp>
+      <p:sp>
+        <p:nvSpPr>
+          <p:cNvPr id="7" name="TextBox 6"/>
+          <p:cNvSpPr txBox="1"/>
+          <p:nvPr/>
+        </p:nvSpPr>
+        <p:spPr>
+          <a:xfrm>
+            <a:off x="11109960" y="1463040"/>
+            <a:ext cx="6858000" cy="365760"/>
+          </a:xfrm>
+          <a:prstGeom prst="rect">
+            <a:avLst/>
+          </a:prstGeom>
+          <a:noFill/>
+        </p:spPr>
+        <p:txBody>
+          <a:bodyPr wrap="square">
+            <a:spAutoFit/>
+          </a:bodyPr>
+          <a:lstStyle/>
+          <a:p>
+            <a:pPr algn="l"/>
+            <a:r>
+              <a:rPr sz="1600" b="0" i="0">
+                <a:solidFill>
+                  <a:srgbClr val="55657A"/>
+                </a:solidFill>
+                <a:latin typeface="Calibri Light"/>
+              </a:rPr>
+              <a:t>k</a:t>
+            </a:r>
+          </a:p>
+        </p:txBody>
+      </p:sp>
+      <p:sp>
+        <p:nvSpPr>
+          <p:cNvPr id="8" name="TextBox 7"/>
+          <p:cNvSpPr txBox="1"/>
+          <p:nvPr/>
+        </p:nvSpPr>
+        <p:spPr>
+          <a:xfrm>
+            <a:off x="11109960" y="1755648"/>
+            <a:ext cx="6858000" cy="1097280"/>
+          </a:xfrm>
+          <a:prstGeom prst="rect">
+            <a:avLst/>
+          </a:prstGeom>
+          <a:noFill/>
+        </p:spPr>
+        <p:txBody>
+          <a:bodyPr wrap="square">
+            <a:spAutoFit/>
+          </a:bodyPr>
+          <a:lstStyle/>
+          <a:p>
+            <a:pPr algn="l"/>
+            <a:r>
+              <a:rPr sz="2800" b="1" i="0">
+                <a:solidFill>
+                  <a:srgbClr val="1B274B"/>
+                </a:solidFill>
+                <a:latin typeface="Calibri"/>
+              </a:rPr>
+              <a:t>0.5898</a:t>
+            </a:r>
+          </a:p>
+        </p:txBody>
+      </p:sp>
+      <p:sp>
+        <p:nvSpPr>
+          <p:cNvPr id="9" name="Rectangle 8"/>
+          <p:cNvSpPr/>
+          <p:nvPr/>
+        </p:nvSpPr>
+        <p:spPr>
+          <a:xfrm>
+            <a:off x="10972800" y="3246120"/>
+            <a:ext cx="7132320" cy="1600200"/>
+          </a:xfrm>
+          <a:prstGeom prst="rect">
+            <a:avLst/>
+          </a:prstGeom>
+          <a:solidFill>
+            <a:srgbClr val="AAD6D4"/>
+          </a:solidFill>
+          <a:ln>
+            <a:noFill/>
+          </a:ln>
+        </p:spPr>
+        <p:style>
+          <a:lnRef idx="1">
+            <a:schemeClr val="accent1"/>
+          </a:lnRef>
+          <a:fillRef idx="3">
+            <a:schemeClr val="accent1"/>
+          </a:fillRef>
+          <a:effectRef idx="2">
+            <a:schemeClr val="accent1"/>
+          </a:effectRef>
+          <a:fontRef idx="minor">
+            <a:schemeClr val="lt1"/>
+          </a:fontRef>
+        </p:style>
+        <p:txBody>
+          <a:bodyPr rtlCol="0" anchor="ctr"/>
+          <a:lstStyle/>
+          <a:p>
+            <a:pPr algn="ctr"/>
+            <a:endParaRPr/>
+          </a:p>
+        </p:txBody>
+      </p:sp>
+      <p:sp>
+        <p:nvSpPr>
+          <p:cNvPr id="10" name="TextBox 9"/>
+          <p:cNvSpPr txBox="1"/>
+          <p:nvPr/>
+        </p:nvSpPr>
+        <p:spPr>
+          <a:xfrm>
+            <a:off x="11109960" y="3337560"/>
+            <a:ext cx="6858000" cy="365760"/>
+          </a:xfrm>
+          <a:prstGeom prst="rect">
+            <a:avLst/>
+          </a:prstGeom>
+          <a:noFill/>
+        </p:spPr>
+        <p:txBody>
+          <a:bodyPr wrap="square">
+            <a:spAutoFit/>
+          </a:bodyPr>
+          <a:lstStyle/>
+          <a:p>
+            <a:pPr algn="l"/>
+            <a:r>
+              <a:rPr sz="1600" b="0" i="0">
+                <a:solidFill>
+                  <a:srgbClr val="55657A"/>
+                </a:solidFill>
+                <a:latin typeface="Calibri Light"/>
+              </a:rPr>
+              <a:t>τ (tau)</a:t>
+            </a:r>
+          </a:p>
+        </p:txBody>
+      </p:sp>
+      <p:sp>
+        <p:nvSpPr>
+          <p:cNvPr id="11" name="TextBox 10"/>
+          <p:cNvSpPr txBox="1"/>
+          <p:nvPr/>
+        </p:nvSpPr>
+        <p:spPr>
+          <a:xfrm>
+            <a:off x="11109960" y="3630168"/>
+            <a:ext cx="6858000" cy="1097280"/>
+          </a:xfrm>
+          <a:prstGeom prst="rect">
+            <a:avLst/>
+          </a:prstGeom>
+          <a:noFill/>
+        </p:spPr>
+        <p:txBody>
+          <a:bodyPr wrap="square">
+            <a:spAutoFit/>
+          </a:bodyPr>
+          <a:lstStyle/>
+          <a:p>
+            <a:pPr algn="l"/>
+            <a:r>
+              <a:rPr sz="2800" b="1" i="0">
+                <a:solidFill>
+                  <a:srgbClr val="1B274B"/>
+                </a:solidFill>
+                <a:latin typeface="Calibri"/>
+              </a:rPr>
+              <a:t>40.5000 s</a:t>
+            </a:r>
+          </a:p>
+        </p:txBody>
+      </p:sp>
+      <p:sp>
+        <p:nvSpPr>
+          <p:cNvPr id="12" name="Rectangle 11"/>
+          <p:cNvSpPr/>
+          <p:nvPr/>
+        </p:nvSpPr>
+        <p:spPr>
+          <a:xfrm>
+            <a:off x="10972800" y="5120640"/>
+            <a:ext cx="7132320" cy="1600200"/>
+          </a:xfrm>
+          <a:prstGeom prst="rect">
+            <a:avLst/>
+          </a:prstGeom>
+          <a:solidFill>
+            <a:srgbClr val="AAD6D4"/>
+          </a:solidFill>
+          <a:ln>
+            <a:noFill/>
+          </a:ln>
+        </p:spPr>
+        <p:style>
+          <a:lnRef idx="1">
+            <a:schemeClr val="accent1"/>
+          </a:lnRef>
+          <a:fillRef idx="3">
+            <a:schemeClr val="accent1"/>
+          </a:fillRef>
+          <a:effectRef idx="2">
+            <a:schemeClr val="accent1"/>
+          </a:effectRef>
+          <a:fontRef idx="minor">
+            <a:schemeClr val="lt1"/>
+          </a:fontRef>
+        </p:style>
+        <p:txBody>
+          <a:bodyPr rtlCol="0" anchor="ctr"/>
+          <a:lstStyle/>
+          <a:p>
+            <a:pPr algn="ctr"/>
+            <a:endParaRPr/>
+          </a:p>
+        </p:txBody>
+      </p:sp>
+      <p:sp>
+        <p:nvSpPr>
+          <p:cNvPr id="13" name="TextBox 12"/>
+          <p:cNvSpPr txBox="1"/>
+          <p:nvPr/>
+        </p:nvSpPr>
+        <p:spPr>
+          <a:xfrm>
+            <a:off x="11109960" y="5212080"/>
+            <a:ext cx="6858000" cy="365760"/>
+          </a:xfrm>
+          <a:prstGeom prst="rect">
+            <a:avLst/>
+          </a:prstGeom>
+          <a:noFill/>
+        </p:spPr>
+        <p:txBody>
+          <a:bodyPr wrap="square">
+            <a:spAutoFit/>
+          </a:bodyPr>
+          <a:lstStyle/>
+          <a:p>
+            <a:pPr algn="l"/>
+            <a:r>
+              <a:rPr sz="1600" b="0" i="0">
+                <a:solidFill>
+                  <a:srgbClr val="55657A"/>
+                </a:solidFill>
+                <a:latin typeface="Calibri Light"/>
+              </a:rPr>
+              <a:t>θ (theta)</a:t>
+            </a:r>
+          </a:p>
+        </p:txBody>
+      </p:sp>
+      <p:sp>
+        <p:nvSpPr>
+          <p:cNvPr id="14" name="TextBox 13"/>
+          <p:cNvSpPr txBox="1"/>
+          <p:nvPr/>
+        </p:nvSpPr>
+        <p:spPr>
+          <a:xfrm>
+            <a:off x="11109960" y="5504688"/>
+            <a:ext cx="6858000" cy="1097280"/>
+          </a:xfrm>
+          <a:prstGeom prst="rect">
+            <a:avLst/>
+          </a:prstGeom>
+          <a:noFill/>
+        </p:spPr>
+        <p:txBody>
+          <a:bodyPr wrap="square">
+            <a:spAutoFit/>
+          </a:bodyPr>
+          <a:lstStyle/>
+          <a:p>
+            <a:pPr algn="l"/>
+            <a:r>
+              <a:rPr sz="2800" b="1" i="0">
+                <a:solidFill>
+                  <a:srgbClr val="1B274B"/>
+                </a:solidFill>
+                <a:latin typeface="Calibri"/>
+              </a:rPr>
+              <a:t>18.0000 s</a:t>
+            </a:r>
+          </a:p>
+        </p:txBody>
+      </p:sp>
+      <p:sp>
+        <p:nvSpPr>
+          <p:cNvPr id="15" name="Rectangle 14"/>
+          <p:cNvSpPr/>
+          <p:nvPr/>
+        </p:nvSpPr>
+        <p:spPr>
+          <a:xfrm>
+            <a:off x="10972800" y="6995160"/>
+            <a:ext cx="7132320" cy="1600200"/>
+          </a:xfrm>
+          <a:prstGeom prst="rect">
+            <a:avLst/>
+          </a:prstGeom>
+          <a:solidFill>
+            <a:srgbClr val="AAD6D4"/>
+          </a:solidFill>
+          <a:ln>
+            <a:noFill/>
+          </a:ln>
+        </p:spPr>
+        <p:style>
+          <a:lnRef idx="1">
+            <a:schemeClr val="accent1"/>
+          </a:lnRef>
+          <a:fillRef idx="3">
+            <a:schemeClr val="accent1"/>
+          </a:fillRef>
+          <a:effectRef idx="2">
+            <a:schemeClr val="accent1"/>
+          </a:effectRef>
+          <a:fontRef idx="minor">
+            <a:schemeClr val="lt1"/>
+          </a:fontRef>
+        </p:style>
+        <p:txBody>
+          <a:bodyPr rtlCol="0" anchor="ctr"/>
+          <a:lstStyle/>
+          <a:p>
+            <a:pPr algn="ctr"/>
+            <a:endParaRPr/>
+          </a:p>
+        </p:txBody>
+      </p:sp>
+      <p:sp>
+        <p:nvSpPr>
+          <p:cNvPr id="16" name="TextBox 15"/>
+          <p:cNvSpPr txBox="1"/>
+          <p:nvPr/>
+        </p:nvSpPr>
+        <p:spPr>
+          <a:xfrm>
+            <a:off x="11109960" y="7086600"/>
+            <a:ext cx="6858000" cy="365760"/>
+          </a:xfrm>
+          <a:prstGeom prst="rect">
+            <a:avLst/>
+          </a:prstGeom>
+          <a:noFill/>
+        </p:spPr>
+        <p:txBody>
+          <a:bodyPr wrap="square">
+            <a:spAutoFit/>
+          </a:bodyPr>
+          <a:lstStyle/>
+          <a:p>
+            <a:pPr algn="l"/>
+            <a:r>
+              <a:rPr sz="1600" b="0" i="0">
+                <a:solidFill>
+                  <a:srgbClr val="55657A"/>
+                </a:solidFill>
+                <a:latin typeface="Calibri Light"/>
+              </a:rPr>
+              <a:t>E (EQM)</a:t>
+            </a:r>
+          </a:p>
+        </p:txBody>
+      </p:sp>
+      <p:sp>
+        <p:nvSpPr>
+          <p:cNvPr id="17" name="TextBox 16"/>
+          <p:cNvSpPr txBox="1"/>
+          <p:nvPr/>
+        </p:nvSpPr>
+        <p:spPr>
+          <a:xfrm>
+            <a:off x="11109960" y="7379208"/>
+            <a:ext cx="6858000" cy="1097280"/>
+          </a:xfrm>
+          <a:prstGeom prst="rect">
+            <a:avLst/>
+          </a:prstGeom>
+          <a:noFill/>
+        </p:spPr>
+        <p:txBody>
+          <a:bodyPr wrap="square">
+            <a:spAutoFit/>
+          </a:bodyPr>
+          <a:lstStyle/>
+          <a:p>
+            <a:pPr algn="l"/>
+            <a:r>
+              <a:rPr sz="2800" b="1" i="0">
+                <a:solidFill>
+                  <a:srgbClr val="1B274B"/>
+                </a:solidFill>
+                <a:latin typeface="Calibri"/>
+              </a:rPr>
+              <a:t>0.2650</a:t>
+            </a:r>
+          </a:p>
+        </p:txBody>
+      </p:sp>
+      <p:sp>
+        <p:nvSpPr>
+          <p:cNvPr id="18" name="TextBox 17"/>
+          <p:cNvSpPr txBox="1"/>
+          <p:nvPr/>
+        </p:nvSpPr>
+        <p:spPr>
+          <a:xfrm>
+            <a:off x="16916400" y="9829800"/>
+            <a:ext cx="1097280" cy="320040"/>
+          </a:xfrm>
+          <a:prstGeom prst="rect">
+            <a:avLst/>
+          </a:prstGeom>
+          <a:noFill/>
+        </p:spPr>
+        <p:txBody>
+          <a:bodyPr wrap="square">
+            <a:spAutoFit/>
+          </a:bodyPr>
+          <a:lstStyle/>
+          <a:p>
+            <a:pPr algn="r"/>
+            <a:r>
+              <a:rPr sz="1000" b="0" i="0">
+                <a:solidFill>
+                  <a:srgbClr val="55657A"/>
+                </a:solidFill>
+                <a:latin typeface="Calibri Light"/>
+              </a:rPr>
+              <a:t>6 / 21</a:t>
+            </a:r>
           </a:p>
         </p:txBody>
       </p:sp>
       <p:pic>
         <p:nvPicPr>
-          <p:cNvPr id="5" name="Picture 4" descr="image7.png"/>
+          <p:cNvPr id="20" name="Imagem 19">
+            <a:extLst>
+              <a:ext uri="{FF2B5EF4-FFF2-40B4-BE49-F238E27FC236}">
+                <a16:creationId xmlns:a16="http://schemas.microsoft.com/office/drawing/2014/main" id="{E9D4AFDA-FDD6-4363-BE22-3537B8B11523}"/>
+              </a:ext>
+            </a:extLst>
+          </p:cNvPr>
           <p:cNvPicPr>
             <a:picLocks noChangeAspect="1"/>
           </p:cNvPicPr>
@@ -12979,501 +13822,14 @@
         </p:blipFill>
         <p:spPr>
           <a:xfrm>
-            <a:off x="365760" y="1371600"/>
-            <a:ext cx="10515600" cy="7498079"/>
+            <a:off x="365760" y="1368093"/>
+            <a:ext cx="10469880" cy="7227267"/>
           </a:xfrm>
           <a:prstGeom prst="rect">
             <a:avLst/>
           </a:prstGeom>
         </p:spPr>
       </p:pic>
-      <p:sp>
-        <p:nvSpPr>
-          <p:cNvPr id="6" name="Rectangle 5"/>
-          <p:cNvSpPr/>
-          <p:nvPr/>
-        </p:nvSpPr>
-        <p:spPr>
-          <a:xfrm>
-            <a:off x="10972800" y="1371600"/>
-            <a:ext cx="7132320" cy="1600200"/>
-          </a:xfrm>
-          <a:prstGeom prst="rect">
-            <a:avLst/>
-          </a:prstGeom>
-          <a:solidFill>
-            <a:srgbClr val="AAD6D4"/>
-          </a:solidFill>
-          <a:ln>
-            <a:noFill/>
-          </a:ln>
-        </p:spPr>
-        <p:style>
-          <a:lnRef idx="1">
-            <a:schemeClr val="accent1"/>
-          </a:lnRef>
-          <a:fillRef idx="3">
-            <a:schemeClr val="accent1"/>
-          </a:fillRef>
-          <a:effectRef idx="2">
-            <a:schemeClr val="accent1"/>
-          </a:effectRef>
-          <a:fontRef idx="minor">
-            <a:schemeClr val="lt1"/>
-          </a:fontRef>
-        </p:style>
-        <p:txBody>
-          <a:bodyPr rtlCol="0" anchor="ctr"/>
-          <a:lstStyle/>
-          <a:p>
-            <a:pPr algn="ctr"/>
-          </a:p>
-        </p:txBody>
-      </p:sp>
-      <p:sp>
-        <p:nvSpPr>
-          <p:cNvPr id="7" name="TextBox 6"/>
-          <p:cNvSpPr txBox="1"/>
-          <p:nvPr/>
-        </p:nvSpPr>
-        <p:spPr>
-          <a:xfrm>
-            <a:off x="11109960" y="1463040"/>
-            <a:ext cx="6858000" cy="365760"/>
-          </a:xfrm>
-          <a:prstGeom prst="rect">
-            <a:avLst/>
-          </a:prstGeom>
-          <a:noFill/>
-        </p:spPr>
-        <p:txBody>
-          <a:bodyPr wrap="square">
-            <a:spAutoFit/>
-          </a:bodyPr>
-          <a:lstStyle/>
-          <a:p>
-            <a:pPr algn="l"/>
-            <a:r>
-              <a:rPr sz="1600" b="0" i="0">
-                <a:solidFill>
-                  <a:srgbClr val="55657A"/>
-                </a:solidFill>
-                <a:latin typeface="Calibri Light"/>
-              </a:rPr>
-              <a:t>k</a:t>
-            </a:r>
-          </a:p>
-        </p:txBody>
-      </p:sp>
-      <p:sp>
-        <p:nvSpPr>
-          <p:cNvPr id="8" name="TextBox 7"/>
-          <p:cNvSpPr txBox="1"/>
-          <p:nvPr/>
-        </p:nvSpPr>
-        <p:spPr>
-          <a:xfrm>
-            <a:off x="11109960" y="1755648"/>
-            <a:ext cx="6858000" cy="1097280"/>
-          </a:xfrm>
-          <a:prstGeom prst="rect">
-            <a:avLst/>
-          </a:prstGeom>
-          <a:noFill/>
-        </p:spPr>
-        <p:txBody>
-          <a:bodyPr wrap="square">
-            <a:spAutoFit/>
-          </a:bodyPr>
-          <a:lstStyle/>
-          <a:p>
-            <a:pPr algn="l"/>
-            <a:r>
-              <a:rPr sz="2800" b="1" i="0">
-                <a:solidFill>
-                  <a:srgbClr val="1B274B"/>
-                </a:solidFill>
-                <a:latin typeface="Calibri"/>
-              </a:rPr>
-              <a:t>0.5898</a:t>
-            </a:r>
-          </a:p>
-        </p:txBody>
-      </p:sp>
-      <p:sp>
-        <p:nvSpPr>
-          <p:cNvPr id="9" name="Rectangle 8"/>
-          <p:cNvSpPr/>
-          <p:nvPr/>
-        </p:nvSpPr>
-        <p:spPr>
-          <a:xfrm>
-            <a:off x="10972800" y="3246120"/>
-            <a:ext cx="7132320" cy="1600200"/>
-          </a:xfrm>
-          <a:prstGeom prst="rect">
-            <a:avLst/>
-          </a:prstGeom>
-          <a:solidFill>
-            <a:srgbClr val="AAD6D4"/>
-          </a:solidFill>
-          <a:ln>
-            <a:noFill/>
-          </a:ln>
-        </p:spPr>
-        <p:style>
-          <a:lnRef idx="1">
-            <a:schemeClr val="accent1"/>
-          </a:lnRef>
-          <a:fillRef idx="3">
-            <a:schemeClr val="accent1"/>
-          </a:fillRef>
-          <a:effectRef idx="2">
-            <a:schemeClr val="accent1"/>
-          </a:effectRef>
-          <a:fontRef idx="minor">
-            <a:schemeClr val="lt1"/>
-          </a:fontRef>
-        </p:style>
-        <p:txBody>
-          <a:bodyPr rtlCol="0" anchor="ctr"/>
-          <a:lstStyle/>
-          <a:p>
-            <a:pPr algn="ctr"/>
-          </a:p>
-        </p:txBody>
-      </p:sp>
-      <p:sp>
-        <p:nvSpPr>
-          <p:cNvPr id="10" name="TextBox 9"/>
-          <p:cNvSpPr txBox="1"/>
-          <p:nvPr/>
-        </p:nvSpPr>
-        <p:spPr>
-          <a:xfrm>
-            <a:off x="11109960" y="3337560"/>
-            <a:ext cx="6858000" cy="365760"/>
-          </a:xfrm>
-          <a:prstGeom prst="rect">
-            <a:avLst/>
-          </a:prstGeom>
-          <a:noFill/>
-        </p:spPr>
-        <p:txBody>
-          <a:bodyPr wrap="square">
-            <a:spAutoFit/>
-          </a:bodyPr>
-          <a:lstStyle/>
-          <a:p>
-            <a:pPr algn="l"/>
-            <a:r>
-              <a:rPr sz="1600" b="0" i="0">
-                <a:solidFill>
-                  <a:srgbClr val="55657A"/>
-                </a:solidFill>
-                <a:latin typeface="Calibri Light"/>
-              </a:rPr>
-              <a:t>τ (tau)</a:t>
-            </a:r>
-          </a:p>
-        </p:txBody>
-      </p:sp>
-      <p:sp>
-        <p:nvSpPr>
-          <p:cNvPr id="11" name="TextBox 10"/>
-          <p:cNvSpPr txBox="1"/>
-          <p:nvPr/>
-        </p:nvSpPr>
-        <p:spPr>
-          <a:xfrm>
-            <a:off x="11109960" y="3630168"/>
-            <a:ext cx="6858000" cy="1097280"/>
-          </a:xfrm>
-          <a:prstGeom prst="rect">
-            <a:avLst/>
-          </a:prstGeom>
-          <a:noFill/>
-        </p:spPr>
-        <p:txBody>
-          <a:bodyPr wrap="square">
-            <a:spAutoFit/>
-          </a:bodyPr>
-          <a:lstStyle/>
-          <a:p>
-            <a:pPr algn="l"/>
-            <a:r>
-              <a:rPr sz="2800" b="1" i="0">
-                <a:solidFill>
-                  <a:srgbClr val="1B274B"/>
-                </a:solidFill>
-                <a:latin typeface="Calibri"/>
-              </a:rPr>
-              <a:t>40.5000 s</a:t>
-            </a:r>
-          </a:p>
-        </p:txBody>
-      </p:sp>
-      <p:sp>
-        <p:nvSpPr>
-          <p:cNvPr id="12" name="Rectangle 11"/>
-          <p:cNvSpPr/>
-          <p:nvPr/>
-        </p:nvSpPr>
-        <p:spPr>
-          <a:xfrm>
-            <a:off x="10972800" y="5120640"/>
-            <a:ext cx="7132320" cy="1600200"/>
-          </a:xfrm>
-          <a:prstGeom prst="rect">
-            <a:avLst/>
-          </a:prstGeom>
-          <a:solidFill>
-            <a:srgbClr val="AAD6D4"/>
-          </a:solidFill>
-          <a:ln>
-            <a:noFill/>
-          </a:ln>
-        </p:spPr>
-        <p:style>
-          <a:lnRef idx="1">
-            <a:schemeClr val="accent1"/>
-          </a:lnRef>
-          <a:fillRef idx="3">
-            <a:schemeClr val="accent1"/>
-          </a:fillRef>
-          <a:effectRef idx="2">
-            <a:schemeClr val="accent1"/>
-          </a:effectRef>
-          <a:fontRef idx="minor">
-            <a:schemeClr val="lt1"/>
-          </a:fontRef>
-        </p:style>
-        <p:txBody>
-          <a:bodyPr rtlCol="0" anchor="ctr"/>
-          <a:lstStyle/>
-          <a:p>
-            <a:pPr algn="ctr"/>
-          </a:p>
-        </p:txBody>
-      </p:sp>
-      <p:sp>
-        <p:nvSpPr>
-          <p:cNvPr id="13" name="TextBox 12"/>
-          <p:cNvSpPr txBox="1"/>
-          <p:nvPr/>
-        </p:nvSpPr>
-        <p:spPr>
-          <a:xfrm>
-            <a:off x="11109960" y="5212080"/>
-            <a:ext cx="6858000" cy="365760"/>
-          </a:xfrm>
-          <a:prstGeom prst="rect">
-            <a:avLst/>
-          </a:prstGeom>
-          <a:noFill/>
-        </p:spPr>
-        <p:txBody>
-          <a:bodyPr wrap="square">
-            <a:spAutoFit/>
-          </a:bodyPr>
-          <a:lstStyle/>
-          <a:p>
-            <a:pPr algn="l"/>
-            <a:r>
-              <a:rPr sz="1600" b="0" i="0">
-                <a:solidFill>
-                  <a:srgbClr val="55657A"/>
-                </a:solidFill>
-                <a:latin typeface="Calibri Light"/>
-              </a:rPr>
-              <a:t>θ (theta)</a:t>
-            </a:r>
-          </a:p>
-        </p:txBody>
-      </p:sp>
-      <p:sp>
-        <p:nvSpPr>
-          <p:cNvPr id="14" name="TextBox 13"/>
-          <p:cNvSpPr txBox="1"/>
-          <p:nvPr/>
-        </p:nvSpPr>
-        <p:spPr>
-          <a:xfrm>
-            <a:off x="11109960" y="5504688"/>
-            <a:ext cx="6858000" cy="1097280"/>
-          </a:xfrm>
-          <a:prstGeom prst="rect">
-            <a:avLst/>
-          </a:prstGeom>
-          <a:noFill/>
-        </p:spPr>
-        <p:txBody>
-          <a:bodyPr wrap="square">
-            <a:spAutoFit/>
-          </a:bodyPr>
-          <a:lstStyle/>
-          <a:p>
-            <a:pPr algn="l"/>
-            <a:r>
-              <a:rPr sz="2800" b="1" i="0">
-                <a:solidFill>
-                  <a:srgbClr val="1B274B"/>
-                </a:solidFill>
-                <a:latin typeface="Calibri"/>
-              </a:rPr>
-              <a:t>18.0000 s</a:t>
-            </a:r>
-          </a:p>
-        </p:txBody>
-      </p:sp>
-      <p:sp>
-        <p:nvSpPr>
-          <p:cNvPr id="15" name="Rectangle 14"/>
-          <p:cNvSpPr/>
-          <p:nvPr/>
-        </p:nvSpPr>
-        <p:spPr>
-          <a:xfrm>
-            <a:off x="10972800" y="6995160"/>
-            <a:ext cx="7132320" cy="1600200"/>
-          </a:xfrm>
-          <a:prstGeom prst="rect">
-            <a:avLst/>
-          </a:prstGeom>
-          <a:solidFill>
-            <a:srgbClr val="AAD6D4"/>
-          </a:solidFill>
-          <a:ln>
-            <a:noFill/>
-          </a:ln>
-        </p:spPr>
-        <p:style>
-          <a:lnRef idx="1">
-            <a:schemeClr val="accent1"/>
-          </a:lnRef>
-          <a:fillRef idx="3">
-            <a:schemeClr val="accent1"/>
-          </a:fillRef>
-          <a:effectRef idx="2">
-            <a:schemeClr val="accent1"/>
-          </a:effectRef>
-          <a:fontRef idx="minor">
-            <a:schemeClr val="lt1"/>
-          </a:fontRef>
-        </p:style>
-        <p:txBody>
-          <a:bodyPr rtlCol="0" anchor="ctr"/>
-          <a:lstStyle/>
-          <a:p>
-            <a:pPr algn="ctr"/>
-          </a:p>
-        </p:txBody>
-      </p:sp>
-      <p:sp>
-        <p:nvSpPr>
-          <p:cNvPr id="16" name="TextBox 15"/>
-          <p:cNvSpPr txBox="1"/>
-          <p:nvPr/>
-        </p:nvSpPr>
-        <p:spPr>
-          <a:xfrm>
-            <a:off x="11109960" y="7086600"/>
-            <a:ext cx="6858000" cy="365760"/>
-          </a:xfrm>
-          <a:prstGeom prst="rect">
-            <a:avLst/>
-          </a:prstGeom>
-          <a:noFill/>
-        </p:spPr>
-        <p:txBody>
-          <a:bodyPr wrap="square">
-            <a:spAutoFit/>
-          </a:bodyPr>
-          <a:lstStyle/>
-          <a:p>
-            <a:pPr algn="l"/>
-            <a:r>
-              <a:rPr sz="1600" b="0" i="0">
-                <a:solidFill>
-                  <a:srgbClr val="55657A"/>
-                </a:solidFill>
-                <a:latin typeface="Calibri Light"/>
-              </a:rPr>
-              <a:t>E (EQM)</a:t>
-            </a:r>
-          </a:p>
-        </p:txBody>
-      </p:sp>
-      <p:sp>
-        <p:nvSpPr>
-          <p:cNvPr id="17" name="TextBox 16"/>
-          <p:cNvSpPr txBox="1"/>
-          <p:nvPr/>
-        </p:nvSpPr>
-        <p:spPr>
-          <a:xfrm>
-            <a:off x="11109960" y="7379208"/>
-            <a:ext cx="6858000" cy="1097280"/>
-          </a:xfrm>
-          <a:prstGeom prst="rect">
-            <a:avLst/>
-          </a:prstGeom>
-          <a:noFill/>
-        </p:spPr>
-        <p:txBody>
-          <a:bodyPr wrap="square">
-            <a:spAutoFit/>
-          </a:bodyPr>
-          <a:lstStyle/>
-          <a:p>
-            <a:pPr algn="l"/>
-            <a:r>
-              <a:rPr sz="2800" b="1" i="0">
-                <a:solidFill>
-                  <a:srgbClr val="1B274B"/>
-                </a:solidFill>
-                <a:latin typeface="Calibri"/>
-              </a:rPr>
-              <a:t>0.2650</a:t>
-            </a:r>
-          </a:p>
-        </p:txBody>
-      </p:sp>
-      <p:sp>
-        <p:nvSpPr>
-          <p:cNvPr id="18" name="TextBox 17"/>
-          <p:cNvSpPr txBox="1"/>
-          <p:nvPr/>
-        </p:nvSpPr>
-        <p:spPr>
-          <a:xfrm>
-            <a:off x="16916400" y="9829800"/>
-            <a:ext cx="1097280" cy="320040"/>
-          </a:xfrm>
-          <a:prstGeom prst="rect">
-            <a:avLst/>
-          </a:prstGeom>
-          <a:noFill/>
-        </p:spPr>
-        <p:txBody>
-          <a:bodyPr wrap="square">
-            <a:spAutoFit/>
-          </a:bodyPr>
-          <a:lstStyle/>
-          <a:p>
-            <a:pPr algn="r"/>
-            <a:r>
-              <a:rPr sz="1000" b="0" i="0">
-                <a:solidFill>
-                  <a:srgbClr val="55657A"/>
-                </a:solidFill>
-                <a:latin typeface="Calibri Light"/>
-              </a:rPr>
-              <a:t>6 / 21</a:t>
-            </a:r>
-          </a:p>
-        </p:txBody>
-      </p:sp>
     </p:spTree>
   </p:cSld>
   <p:clrMapOvr>
@@ -13483,7 +13839,7 @@
 </file>
 
 <file path=ppt/slides/slide7.xml><?xml version="1.0" encoding="utf-8"?>
-<p:sld xmlns:a="http://schemas.openxmlformats.org/drawingml/2006/main" xmlns:p="http://schemas.openxmlformats.org/presentationml/2006/main" xmlns:r="http://schemas.openxmlformats.org/officeDocument/2006/relationships">
+<p:sld xmlns:a="http://schemas.openxmlformats.org/drawingml/2006/main" xmlns:r="http://schemas.openxmlformats.org/officeDocument/2006/relationships" xmlns:p="http://schemas.openxmlformats.org/presentationml/2006/main">
   <p:cSld>
     <p:bg>
       <p:bgPr>
@@ -13499,7 +13855,14 @@
         <p:cNvGrpSpPr/>
         <p:nvPr/>
       </p:nvGrpSpPr>
-      <p:grpSpPr/>
+      <p:grpSpPr>
+        <a:xfrm>
+          <a:off x="0" y="0"/>
+          <a:ext cx="0" cy="0"/>
+          <a:chOff x="0" y="0"/>
+          <a:chExt cx="0" cy="0"/>
+        </a:xfrm>
+      </p:grpSpPr>
       <p:sp>
         <p:nvSpPr>
           <p:cNvPr id="2" name="Rectangle 1"/>
@@ -13540,6 +13903,7 @@
           <a:lstStyle/>
           <a:p>
             <a:pPr algn="ctr"/>
+            <a:endParaRPr/>
           </a:p>
         </p:txBody>
       </p:sp>
@@ -13618,12 +13982,510 @@
           <a:lstStyle/>
           <a:p>
             <a:pPr algn="ctr"/>
+            <a:endParaRPr/>
+          </a:p>
+        </p:txBody>
+      </p:sp>
+      <p:sp>
+        <p:nvSpPr>
+          <p:cNvPr id="6" name="Rectangle 5"/>
+          <p:cNvSpPr/>
+          <p:nvPr/>
+        </p:nvSpPr>
+        <p:spPr>
+          <a:xfrm>
+            <a:off x="10972800" y="1371600"/>
+            <a:ext cx="7132320" cy="1600200"/>
+          </a:xfrm>
+          <a:prstGeom prst="rect">
+            <a:avLst/>
+          </a:prstGeom>
+          <a:solidFill>
+            <a:srgbClr val="AAD6D4"/>
+          </a:solidFill>
+          <a:ln>
+            <a:noFill/>
+          </a:ln>
+        </p:spPr>
+        <p:style>
+          <a:lnRef idx="1">
+            <a:schemeClr val="accent1"/>
+          </a:lnRef>
+          <a:fillRef idx="3">
+            <a:schemeClr val="accent1"/>
+          </a:fillRef>
+          <a:effectRef idx="2">
+            <a:schemeClr val="accent1"/>
+          </a:effectRef>
+          <a:fontRef idx="minor">
+            <a:schemeClr val="lt1"/>
+          </a:fontRef>
+        </p:style>
+        <p:txBody>
+          <a:bodyPr rtlCol="0" anchor="ctr"/>
+          <a:lstStyle/>
+          <a:p>
+            <a:pPr algn="ctr"/>
+            <a:endParaRPr/>
+          </a:p>
+        </p:txBody>
+      </p:sp>
+      <p:sp>
+        <p:nvSpPr>
+          <p:cNvPr id="7" name="TextBox 6"/>
+          <p:cNvSpPr txBox="1"/>
+          <p:nvPr/>
+        </p:nvSpPr>
+        <p:spPr>
+          <a:xfrm>
+            <a:off x="11109960" y="1463040"/>
+            <a:ext cx="6858000" cy="365760"/>
+          </a:xfrm>
+          <a:prstGeom prst="rect">
+            <a:avLst/>
+          </a:prstGeom>
+          <a:noFill/>
+        </p:spPr>
+        <p:txBody>
+          <a:bodyPr wrap="square">
+            <a:spAutoFit/>
+          </a:bodyPr>
+          <a:lstStyle/>
+          <a:p>
+            <a:pPr algn="l"/>
+            <a:r>
+              <a:rPr sz="1600" b="0" i="0">
+                <a:solidFill>
+                  <a:srgbClr val="55657A"/>
+                </a:solidFill>
+                <a:latin typeface="Calibri Light"/>
+              </a:rPr>
+              <a:t>k</a:t>
+            </a:r>
+          </a:p>
+        </p:txBody>
+      </p:sp>
+      <p:sp>
+        <p:nvSpPr>
+          <p:cNvPr id="8" name="TextBox 7"/>
+          <p:cNvSpPr txBox="1"/>
+          <p:nvPr/>
+        </p:nvSpPr>
+        <p:spPr>
+          <a:xfrm>
+            <a:off x="11109960" y="1755648"/>
+            <a:ext cx="6858000" cy="1097280"/>
+          </a:xfrm>
+          <a:prstGeom prst="rect">
+            <a:avLst/>
+          </a:prstGeom>
+          <a:noFill/>
+        </p:spPr>
+        <p:txBody>
+          <a:bodyPr wrap="square">
+            <a:spAutoFit/>
+          </a:bodyPr>
+          <a:lstStyle/>
+          <a:p>
+            <a:pPr algn="l"/>
+            <a:r>
+              <a:rPr sz="2800" b="1" i="0">
+                <a:solidFill>
+                  <a:srgbClr val="1B274B"/>
+                </a:solidFill>
+                <a:latin typeface="Calibri"/>
+              </a:rPr>
+              <a:t>0.5898</a:t>
+            </a:r>
+          </a:p>
+        </p:txBody>
+      </p:sp>
+      <p:sp>
+        <p:nvSpPr>
+          <p:cNvPr id="9" name="Rectangle 8"/>
+          <p:cNvSpPr/>
+          <p:nvPr/>
+        </p:nvSpPr>
+        <p:spPr>
+          <a:xfrm>
+            <a:off x="10972800" y="3246120"/>
+            <a:ext cx="7132320" cy="1600200"/>
+          </a:xfrm>
+          <a:prstGeom prst="rect">
+            <a:avLst/>
+          </a:prstGeom>
+          <a:solidFill>
+            <a:srgbClr val="AAD6D4"/>
+          </a:solidFill>
+          <a:ln>
+            <a:noFill/>
+          </a:ln>
+        </p:spPr>
+        <p:style>
+          <a:lnRef idx="1">
+            <a:schemeClr val="accent1"/>
+          </a:lnRef>
+          <a:fillRef idx="3">
+            <a:schemeClr val="accent1"/>
+          </a:fillRef>
+          <a:effectRef idx="2">
+            <a:schemeClr val="accent1"/>
+          </a:effectRef>
+          <a:fontRef idx="minor">
+            <a:schemeClr val="lt1"/>
+          </a:fontRef>
+        </p:style>
+        <p:txBody>
+          <a:bodyPr rtlCol="0" anchor="ctr"/>
+          <a:lstStyle/>
+          <a:p>
+            <a:pPr algn="ctr"/>
+            <a:endParaRPr/>
+          </a:p>
+        </p:txBody>
+      </p:sp>
+      <p:sp>
+        <p:nvSpPr>
+          <p:cNvPr id="10" name="TextBox 9"/>
+          <p:cNvSpPr txBox="1"/>
+          <p:nvPr/>
+        </p:nvSpPr>
+        <p:spPr>
+          <a:xfrm>
+            <a:off x="11109960" y="3337560"/>
+            <a:ext cx="6858000" cy="365760"/>
+          </a:xfrm>
+          <a:prstGeom prst="rect">
+            <a:avLst/>
+          </a:prstGeom>
+          <a:noFill/>
+        </p:spPr>
+        <p:txBody>
+          <a:bodyPr wrap="square">
+            <a:spAutoFit/>
+          </a:bodyPr>
+          <a:lstStyle/>
+          <a:p>
+            <a:pPr algn="l"/>
+            <a:r>
+              <a:rPr sz="1600" b="0" i="0">
+                <a:solidFill>
+                  <a:srgbClr val="55657A"/>
+                </a:solidFill>
+                <a:latin typeface="Calibri Light"/>
+              </a:rPr>
+              <a:t>τ (tau)</a:t>
+            </a:r>
+          </a:p>
+        </p:txBody>
+      </p:sp>
+      <p:sp>
+        <p:nvSpPr>
+          <p:cNvPr id="11" name="TextBox 10"/>
+          <p:cNvSpPr txBox="1"/>
+          <p:nvPr/>
+        </p:nvSpPr>
+        <p:spPr>
+          <a:xfrm>
+            <a:off x="11109960" y="3630168"/>
+            <a:ext cx="6858000" cy="1097280"/>
+          </a:xfrm>
+          <a:prstGeom prst="rect">
+            <a:avLst/>
+          </a:prstGeom>
+          <a:noFill/>
+        </p:spPr>
+        <p:txBody>
+          <a:bodyPr wrap="square">
+            <a:spAutoFit/>
+          </a:bodyPr>
+          <a:lstStyle/>
+          <a:p>
+            <a:pPr algn="l"/>
+            <a:r>
+              <a:rPr sz="2800" b="1" i="0">
+                <a:solidFill>
+                  <a:srgbClr val="1B274B"/>
+                </a:solidFill>
+                <a:latin typeface="Calibri"/>
+              </a:rPr>
+              <a:t>40.6667 s</a:t>
+            </a:r>
+          </a:p>
+        </p:txBody>
+      </p:sp>
+      <p:sp>
+        <p:nvSpPr>
+          <p:cNvPr id="12" name="Rectangle 11"/>
+          <p:cNvSpPr/>
+          <p:nvPr/>
+        </p:nvSpPr>
+        <p:spPr>
+          <a:xfrm>
+            <a:off x="10972800" y="5120640"/>
+            <a:ext cx="7132320" cy="1600200"/>
+          </a:xfrm>
+          <a:prstGeom prst="rect">
+            <a:avLst/>
+          </a:prstGeom>
+          <a:solidFill>
+            <a:srgbClr val="AAD6D4"/>
+          </a:solidFill>
+          <a:ln>
+            <a:noFill/>
+          </a:ln>
+        </p:spPr>
+        <p:style>
+          <a:lnRef idx="1">
+            <a:schemeClr val="accent1"/>
+          </a:lnRef>
+          <a:fillRef idx="3">
+            <a:schemeClr val="accent1"/>
+          </a:fillRef>
+          <a:effectRef idx="2">
+            <a:schemeClr val="accent1"/>
+          </a:effectRef>
+          <a:fontRef idx="minor">
+            <a:schemeClr val="lt1"/>
+          </a:fontRef>
+        </p:style>
+        <p:txBody>
+          <a:bodyPr rtlCol="0" anchor="ctr"/>
+          <a:lstStyle/>
+          <a:p>
+            <a:pPr algn="ctr"/>
+            <a:endParaRPr/>
+          </a:p>
+        </p:txBody>
+      </p:sp>
+      <p:sp>
+        <p:nvSpPr>
+          <p:cNvPr id="13" name="TextBox 12"/>
+          <p:cNvSpPr txBox="1"/>
+          <p:nvPr/>
+        </p:nvSpPr>
+        <p:spPr>
+          <a:xfrm>
+            <a:off x="11109960" y="5212080"/>
+            <a:ext cx="6858000" cy="365760"/>
+          </a:xfrm>
+          <a:prstGeom prst="rect">
+            <a:avLst/>
+          </a:prstGeom>
+          <a:noFill/>
+        </p:spPr>
+        <p:txBody>
+          <a:bodyPr wrap="square">
+            <a:spAutoFit/>
+          </a:bodyPr>
+          <a:lstStyle/>
+          <a:p>
+            <a:pPr algn="l"/>
+            <a:r>
+              <a:rPr sz="1600" b="0" i="0">
+                <a:solidFill>
+                  <a:srgbClr val="55657A"/>
+                </a:solidFill>
+                <a:latin typeface="Calibri Light"/>
+              </a:rPr>
+              <a:t>θ (theta)</a:t>
+            </a:r>
+          </a:p>
+        </p:txBody>
+      </p:sp>
+      <p:sp>
+        <p:nvSpPr>
+          <p:cNvPr id="14" name="TextBox 13"/>
+          <p:cNvSpPr txBox="1"/>
+          <p:nvPr/>
+        </p:nvSpPr>
+        <p:spPr>
+          <a:xfrm>
+            <a:off x="11109960" y="5504688"/>
+            <a:ext cx="6858000" cy="1097280"/>
+          </a:xfrm>
+          <a:prstGeom prst="rect">
+            <a:avLst/>
+          </a:prstGeom>
+          <a:noFill/>
+        </p:spPr>
+        <p:txBody>
+          <a:bodyPr wrap="square">
+            <a:spAutoFit/>
+          </a:bodyPr>
+          <a:lstStyle/>
+          <a:p>
+            <a:pPr algn="l"/>
+            <a:r>
+              <a:rPr sz="2800" b="1" i="0">
+                <a:solidFill>
+                  <a:srgbClr val="1B274B"/>
+                </a:solidFill>
+                <a:latin typeface="Calibri"/>
+              </a:rPr>
+              <a:t>18.1650 s</a:t>
+            </a:r>
+          </a:p>
+        </p:txBody>
+      </p:sp>
+      <p:sp>
+        <p:nvSpPr>
+          <p:cNvPr id="15" name="Rectangle 14"/>
+          <p:cNvSpPr/>
+          <p:nvPr/>
+        </p:nvSpPr>
+        <p:spPr>
+          <a:xfrm>
+            <a:off x="10972800" y="6995160"/>
+            <a:ext cx="7132320" cy="1600200"/>
+          </a:xfrm>
+          <a:prstGeom prst="rect">
+            <a:avLst/>
+          </a:prstGeom>
+          <a:solidFill>
+            <a:srgbClr val="AAD6D4"/>
+          </a:solidFill>
+          <a:ln>
+            <a:noFill/>
+          </a:ln>
+        </p:spPr>
+        <p:style>
+          <a:lnRef idx="1">
+            <a:schemeClr val="accent1"/>
+          </a:lnRef>
+          <a:fillRef idx="3">
+            <a:schemeClr val="accent1"/>
+          </a:fillRef>
+          <a:effectRef idx="2">
+            <a:schemeClr val="accent1"/>
+          </a:effectRef>
+          <a:fontRef idx="minor">
+            <a:schemeClr val="lt1"/>
+          </a:fontRef>
+        </p:style>
+        <p:txBody>
+          <a:bodyPr rtlCol="0" anchor="ctr"/>
+          <a:lstStyle/>
+          <a:p>
+            <a:pPr algn="ctr"/>
+            <a:endParaRPr/>
+          </a:p>
+        </p:txBody>
+      </p:sp>
+      <p:sp>
+        <p:nvSpPr>
+          <p:cNvPr id="16" name="TextBox 15"/>
+          <p:cNvSpPr txBox="1"/>
+          <p:nvPr/>
+        </p:nvSpPr>
+        <p:spPr>
+          <a:xfrm>
+            <a:off x="11109960" y="7086600"/>
+            <a:ext cx="6858000" cy="365760"/>
+          </a:xfrm>
+          <a:prstGeom prst="rect">
+            <a:avLst/>
+          </a:prstGeom>
+          <a:noFill/>
+        </p:spPr>
+        <p:txBody>
+          <a:bodyPr wrap="square">
+            <a:spAutoFit/>
+          </a:bodyPr>
+          <a:lstStyle/>
+          <a:p>
+            <a:pPr algn="l"/>
+            <a:r>
+              <a:rPr sz="1600" b="0" i="0">
+                <a:solidFill>
+                  <a:srgbClr val="55657A"/>
+                </a:solidFill>
+                <a:latin typeface="Calibri Light"/>
+              </a:rPr>
+              <a:t>E (EQM)</a:t>
+            </a:r>
+          </a:p>
+        </p:txBody>
+      </p:sp>
+      <p:sp>
+        <p:nvSpPr>
+          <p:cNvPr id="17" name="TextBox 16"/>
+          <p:cNvSpPr txBox="1"/>
+          <p:nvPr/>
+        </p:nvSpPr>
+        <p:spPr>
+          <a:xfrm>
+            <a:off x="11109960" y="7379208"/>
+            <a:ext cx="6858000" cy="1097280"/>
+          </a:xfrm>
+          <a:prstGeom prst="rect">
+            <a:avLst/>
+          </a:prstGeom>
+          <a:noFill/>
+        </p:spPr>
+        <p:txBody>
+          <a:bodyPr wrap="square">
+            <a:spAutoFit/>
+          </a:bodyPr>
+          <a:lstStyle/>
+          <a:p>
+            <a:pPr algn="l"/>
+            <a:r>
+              <a:rPr sz="2800" b="1" i="0">
+                <a:solidFill>
+                  <a:srgbClr val="1B274B"/>
+                </a:solidFill>
+                <a:latin typeface="Calibri"/>
+              </a:rPr>
+              <a:t>0.3166</a:t>
+            </a:r>
+          </a:p>
+        </p:txBody>
+      </p:sp>
+      <p:sp>
+        <p:nvSpPr>
+          <p:cNvPr id="18" name="TextBox 17"/>
+          <p:cNvSpPr txBox="1"/>
+          <p:nvPr/>
+        </p:nvSpPr>
+        <p:spPr>
+          <a:xfrm>
+            <a:off x="16916400" y="9829800"/>
+            <a:ext cx="1097280" cy="320040"/>
+          </a:xfrm>
+          <a:prstGeom prst="rect">
+            <a:avLst/>
+          </a:prstGeom>
+          <a:noFill/>
+        </p:spPr>
+        <p:txBody>
+          <a:bodyPr wrap="square">
+            <a:spAutoFit/>
+          </a:bodyPr>
+          <a:lstStyle/>
+          <a:p>
+            <a:pPr algn="r"/>
+            <a:r>
+              <a:rPr sz="1000" b="0" i="0">
+                <a:solidFill>
+                  <a:srgbClr val="55657A"/>
+                </a:solidFill>
+                <a:latin typeface="Calibri Light"/>
+              </a:rPr>
+              <a:t>7 / 21</a:t>
+            </a:r>
           </a:p>
         </p:txBody>
       </p:sp>
       <p:pic>
         <p:nvPicPr>
-          <p:cNvPr id="5" name="Picture 4" descr="image11.png"/>
+          <p:cNvPr id="20" name="Imagem 19">
+            <a:extLst>
+              <a:ext uri="{FF2B5EF4-FFF2-40B4-BE49-F238E27FC236}">
+                <a16:creationId xmlns:a16="http://schemas.microsoft.com/office/drawing/2014/main" id="{141F5AAA-CC5D-48ED-825A-3F84CF9CF501}"/>
+              </a:ext>
+            </a:extLst>
+          </p:cNvPr>
           <p:cNvPicPr>
             <a:picLocks noChangeAspect="1"/>
           </p:cNvPicPr>
@@ -13638,500 +14500,13 @@
         <p:spPr>
           <a:xfrm>
             <a:off x="365760" y="1371600"/>
-            <a:ext cx="10515600" cy="7498079"/>
+            <a:ext cx="10469880" cy="7223760"/>
           </a:xfrm>
           <a:prstGeom prst="rect">
             <a:avLst/>
           </a:prstGeom>
         </p:spPr>
       </p:pic>
-      <p:sp>
-        <p:nvSpPr>
-          <p:cNvPr id="6" name="Rectangle 5"/>
-          <p:cNvSpPr/>
-          <p:nvPr/>
-        </p:nvSpPr>
-        <p:spPr>
-          <a:xfrm>
-            <a:off x="10972800" y="1371600"/>
-            <a:ext cx="7132320" cy="1600200"/>
-          </a:xfrm>
-          <a:prstGeom prst="rect">
-            <a:avLst/>
-          </a:prstGeom>
-          <a:solidFill>
-            <a:srgbClr val="AAD6D4"/>
-          </a:solidFill>
-          <a:ln>
-            <a:noFill/>
-          </a:ln>
-        </p:spPr>
-        <p:style>
-          <a:lnRef idx="1">
-            <a:schemeClr val="accent1"/>
-          </a:lnRef>
-          <a:fillRef idx="3">
-            <a:schemeClr val="accent1"/>
-          </a:fillRef>
-          <a:effectRef idx="2">
-            <a:schemeClr val="accent1"/>
-          </a:effectRef>
-          <a:fontRef idx="minor">
-            <a:schemeClr val="lt1"/>
-          </a:fontRef>
-        </p:style>
-        <p:txBody>
-          <a:bodyPr rtlCol="0" anchor="ctr"/>
-          <a:lstStyle/>
-          <a:p>
-            <a:pPr algn="ctr"/>
-          </a:p>
-        </p:txBody>
-      </p:sp>
-      <p:sp>
-        <p:nvSpPr>
-          <p:cNvPr id="7" name="TextBox 6"/>
-          <p:cNvSpPr txBox="1"/>
-          <p:nvPr/>
-        </p:nvSpPr>
-        <p:spPr>
-          <a:xfrm>
-            <a:off x="11109960" y="1463040"/>
-            <a:ext cx="6858000" cy="365760"/>
-          </a:xfrm>
-          <a:prstGeom prst="rect">
-            <a:avLst/>
-          </a:prstGeom>
-          <a:noFill/>
-        </p:spPr>
-        <p:txBody>
-          <a:bodyPr wrap="square">
-            <a:spAutoFit/>
-          </a:bodyPr>
-          <a:lstStyle/>
-          <a:p>
-            <a:pPr algn="l"/>
-            <a:r>
-              <a:rPr sz="1600" b="0" i="0">
-                <a:solidFill>
-                  <a:srgbClr val="55657A"/>
-                </a:solidFill>
-                <a:latin typeface="Calibri Light"/>
-              </a:rPr>
-              <a:t>k</a:t>
-            </a:r>
-          </a:p>
-        </p:txBody>
-      </p:sp>
-      <p:sp>
-        <p:nvSpPr>
-          <p:cNvPr id="8" name="TextBox 7"/>
-          <p:cNvSpPr txBox="1"/>
-          <p:nvPr/>
-        </p:nvSpPr>
-        <p:spPr>
-          <a:xfrm>
-            <a:off x="11109960" y="1755648"/>
-            <a:ext cx="6858000" cy="1097280"/>
-          </a:xfrm>
-          <a:prstGeom prst="rect">
-            <a:avLst/>
-          </a:prstGeom>
-          <a:noFill/>
-        </p:spPr>
-        <p:txBody>
-          <a:bodyPr wrap="square">
-            <a:spAutoFit/>
-          </a:bodyPr>
-          <a:lstStyle/>
-          <a:p>
-            <a:pPr algn="l"/>
-            <a:r>
-              <a:rPr sz="2800" b="1" i="0">
-                <a:solidFill>
-                  <a:srgbClr val="1B274B"/>
-                </a:solidFill>
-                <a:latin typeface="Calibri"/>
-              </a:rPr>
-              <a:t>0.5898</a:t>
-            </a:r>
-          </a:p>
-        </p:txBody>
-      </p:sp>
-      <p:sp>
-        <p:nvSpPr>
-          <p:cNvPr id="9" name="Rectangle 8"/>
-          <p:cNvSpPr/>
-          <p:nvPr/>
-        </p:nvSpPr>
-        <p:spPr>
-          <a:xfrm>
-            <a:off x="10972800" y="3246120"/>
-            <a:ext cx="7132320" cy="1600200"/>
-          </a:xfrm>
-          <a:prstGeom prst="rect">
-            <a:avLst/>
-          </a:prstGeom>
-          <a:solidFill>
-            <a:srgbClr val="AAD6D4"/>
-          </a:solidFill>
-          <a:ln>
-            <a:noFill/>
-          </a:ln>
-        </p:spPr>
-        <p:style>
-          <a:lnRef idx="1">
-            <a:schemeClr val="accent1"/>
-          </a:lnRef>
-          <a:fillRef idx="3">
-            <a:schemeClr val="accent1"/>
-          </a:fillRef>
-          <a:effectRef idx="2">
-            <a:schemeClr val="accent1"/>
-          </a:effectRef>
-          <a:fontRef idx="minor">
-            <a:schemeClr val="lt1"/>
-          </a:fontRef>
-        </p:style>
-        <p:txBody>
-          <a:bodyPr rtlCol="0" anchor="ctr"/>
-          <a:lstStyle/>
-          <a:p>
-            <a:pPr algn="ctr"/>
-          </a:p>
-        </p:txBody>
-      </p:sp>
-      <p:sp>
-        <p:nvSpPr>
-          <p:cNvPr id="10" name="TextBox 9"/>
-          <p:cNvSpPr txBox="1"/>
-          <p:nvPr/>
-        </p:nvSpPr>
-        <p:spPr>
-          <a:xfrm>
-            <a:off x="11109960" y="3337560"/>
-            <a:ext cx="6858000" cy="365760"/>
-          </a:xfrm>
-          <a:prstGeom prst="rect">
-            <a:avLst/>
-          </a:prstGeom>
-          <a:noFill/>
-        </p:spPr>
-        <p:txBody>
-          <a:bodyPr wrap="square">
-            <a:spAutoFit/>
-          </a:bodyPr>
-          <a:lstStyle/>
-          <a:p>
-            <a:pPr algn="l"/>
-            <a:r>
-              <a:rPr sz="1600" b="0" i="0">
-                <a:solidFill>
-                  <a:srgbClr val="55657A"/>
-                </a:solidFill>
-                <a:latin typeface="Calibri Light"/>
-              </a:rPr>
-              <a:t>τ (tau)</a:t>
-            </a:r>
-          </a:p>
-        </p:txBody>
-      </p:sp>
-      <p:sp>
-        <p:nvSpPr>
-          <p:cNvPr id="11" name="TextBox 10"/>
-          <p:cNvSpPr txBox="1"/>
-          <p:nvPr/>
-        </p:nvSpPr>
-        <p:spPr>
-          <a:xfrm>
-            <a:off x="11109960" y="3630168"/>
-            <a:ext cx="6858000" cy="1097280"/>
-          </a:xfrm>
-          <a:prstGeom prst="rect">
-            <a:avLst/>
-          </a:prstGeom>
-          <a:noFill/>
-        </p:spPr>
-        <p:txBody>
-          <a:bodyPr wrap="square">
-            <a:spAutoFit/>
-          </a:bodyPr>
-          <a:lstStyle/>
-          <a:p>
-            <a:pPr algn="l"/>
-            <a:r>
-              <a:rPr sz="2800" b="1" i="0">
-                <a:solidFill>
-                  <a:srgbClr val="1B274B"/>
-                </a:solidFill>
-                <a:latin typeface="Calibri"/>
-              </a:rPr>
-              <a:t>40.6667 s</a:t>
-            </a:r>
-          </a:p>
-        </p:txBody>
-      </p:sp>
-      <p:sp>
-        <p:nvSpPr>
-          <p:cNvPr id="12" name="Rectangle 11"/>
-          <p:cNvSpPr/>
-          <p:nvPr/>
-        </p:nvSpPr>
-        <p:spPr>
-          <a:xfrm>
-            <a:off x="10972800" y="5120640"/>
-            <a:ext cx="7132320" cy="1600200"/>
-          </a:xfrm>
-          <a:prstGeom prst="rect">
-            <a:avLst/>
-          </a:prstGeom>
-          <a:solidFill>
-            <a:srgbClr val="AAD6D4"/>
-          </a:solidFill>
-          <a:ln>
-            <a:noFill/>
-          </a:ln>
-        </p:spPr>
-        <p:style>
-          <a:lnRef idx="1">
-            <a:schemeClr val="accent1"/>
-          </a:lnRef>
-          <a:fillRef idx="3">
-            <a:schemeClr val="accent1"/>
-          </a:fillRef>
-          <a:effectRef idx="2">
-            <a:schemeClr val="accent1"/>
-          </a:effectRef>
-          <a:fontRef idx="minor">
-            <a:schemeClr val="lt1"/>
-          </a:fontRef>
-        </p:style>
-        <p:txBody>
-          <a:bodyPr rtlCol="0" anchor="ctr"/>
-          <a:lstStyle/>
-          <a:p>
-            <a:pPr algn="ctr"/>
-          </a:p>
-        </p:txBody>
-      </p:sp>
-      <p:sp>
-        <p:nvSpPr>
-          <p:cNvPr id="13" name="TextBox 12"/>
-          <p:cNvSpPr txBox="1"/>
-          <p:nvPr/>
-        </p:nvSpPr>
-        <p:spPr>
-          <a:xfrm>
-            <a:off x="11109960" y="5212080"/>
-            <a:ext cx="6858000" cy="365760"/>
-          </a:xfrm>
-          <a:prstGeom prst="rect">
-            <a:avLst/>
-          </a:prstGeom>
-          <a:noFill/>
-        </p:spPr>
-        <p:txBody>
-          <a:bodyPr wrap="square">
-            <a:spAutoFit/>
-          </a:bodyPr>
-          <a:lstStyle/>
-          <a:p>
-            <a:pPr algn="l"/>
-            <a:r>
-              <a:rPr sz="1600" b="0" i="0">
-                <a:solidFill>
-                  <a:srgbClr val="55657A"/>
-                </a:solidFill>
-                <a:latin typeface="Calibri Light"/>
-              </a:rPr>
-              <a:t>θ (theta)</a:t>
-            </a:r>
-          </a:p>
-        </p:txBody>
-      </p:sp>
-      <p:sp>
-        <p:nvSpPr>
-          <p:cNvPr id="14" name="TextBox 13"/>
-          <p:cNvSpPr txBox="1"/>
-          <p:nvPr/>
-        </p:nvSpPr>
-        <p:spPr>
-          <a:xfrm>
-            <a:off x="11109960" y="5504688"/>
-            <a:ext cx="6858000" cy="1097280"/>
-          </a:xfrm>
-          <a:prstGeom prst="rect">
-            <a:avLst/>
-          </a:prstGeom>
-          <a:noFill/>
-        </p:spPr>
-        <p:txBody>
-          <a:bodyPr wrap="square">
-            <a:spAutoFit/>
-          </a:bodyPr>
-          <a:lstStyle/>
-          <a:p>
-            <a:pPr algn="l"/>
-            <a:r>
-              <a:rPr sz="2800" b="1" i="0">
-                <a:solidFill>
-                  <a:srgbClr val="1B274B"/>
-                </a:solidFill>
-                <a:latin typeface="Calibri"/>
-              </a:rPr>
-              <a:t>18.1650 s</a:t>
-            </a:r>
-          </a:p>
-        </p:txBody>
-      </p:sp>
-      <p:sp>
-        <p:nvSpPr>
-          <p:cNvPr id="15" name="Rectangle 14"/>
-          <p:cNvSpPr/>
-          <p:nvPr/>
-        </p:nvSpPr>
-        <p:spPr>
-          <a:xfrm>
-            <a:off x="10972800" y="6995160"/>
-            <a:ext cx="7132320" cy="1600200"/>
-          </a:xfrm>
-          <a:prstGeom prst="rect">
-            <a:avLst/>
-          </a:prstGeom>
-          <a:solidFill>
-            <a:srgbClr val="AAD6D4"/>
-          </a:solidFill>
-          <a:ln>
-            <a:noFill/>
-          </a:ln>
-        </p:spPr>
-        <p:style>
-          <a:lnRef idx="1">
-            <a:schemeClr val="accent1"/>
-          </a:lnRef>
-          <a:fillRef idx="3">
-            <a:schemeClr val="accent1"/>
-          </a:fillRef>
-          <a:effectRef idx="2">
-            <a:schemeClr val="accent1"/>
-          </a:effectRef>
-          <a:fontRef idx="minor">
-            <a:schemeClr val="lt1"/>
-          </a:fontRef>
-        </p:style>
-        <p:txBody>
-          <a:bodyPr rtlCol="0" anchor="ctr"/>
-          <a:lstStyle/>
-          <a:p>
-            <a:pPr algn="ctr"/>
-          </a:p>
-        </p:txBody>
-      </p:sp>
-      <p:sp>
-        <p:nvSpPr>
-          <p:cNvPr id="16" name="TextBox 15"/>
-          <p:cNvSpPr txBox="1"/>
-          <p:nvPr/>
-        </p:nvSpPr>
-        <p:spPr>
-          <a:xfrm>
-            <a:off x="11109960" y="7086600"/>
-            <a:ext cx="6858000" cy="365760"/>
-          </a:xfrm>
-          <a:prstGeom prst="rect">
-            <a:avLst/>
-          </a:prstGeom>
-          <a:noFill/>
-        </p:spPr>
-        <p:txBody>
-          <a:bodyPr wrap="square">
-            <a:spAutoFit/>
-          </a:bodyPr>
-          <a:lstStyle/>
-          <a:p>
-            <a:pPr algn="l"/>
-            <a:r>
-              <a:rPr sz="1600" b="0" i="0">
-                <a:solidFill>
-                  <a:srgbClr val="55657A"/>
-                </a:solidFill>
-                <a:latin typeface="Calibri Light"/>
-              </a:rPr>
-              <a:t>E (EQM)</a:t>
-            </a:r>
-          </a:p>
-        </p:txBody>
-      </p:sp>
-      <p:sp>
-        <p:nvSpPr>
-          <p:cNvPr id="17" name="TextBox 16"/>
-          <p:cNvSpPr txBox="1"/>
-          <p:nvPr/>
-        </p:nvSpPr>
-        <p:spPr>
-          <a:xfrm>
-            <a:off x="11109960" y="7379208"/>
-            <a:ext cx="6858000" cy="1097280"/>
-          </a:xfrm>
-          <a:prstGeom prst="rect">
-            <a:avLst/>
-          </a:prstGeom>
-          <a:noFill/>
-        </p:spPr>
-        <p:txBody>
-          <a:bodyPr wrap="square">
-            <a:spAutoFit/>
-          </a:bodyPr>
-          <a:lstStyle/>
-          <a:p>
-            <a:pPr algn="l"/>
-            <a:r>
-              <a:rPr sz="2800" b="1" i="0">
-                <a:solidFill>
-                  <a:srgbClr val="1B274B"/>
-                </a:solidFill>
-                <a:latin typeface="Calibri"/>
-              </a:rPr>
-              <a:t>0.3166</a:t>
-            </a:r>
-          </a:p>
-        </p:txBody>
-      </p:sp>
-      <p:sp>
-        <p:nvSpPr>
-          <p:cNvPr id="18" name="TextBox 17"/>
-          <p:cNvSpPr txBox="1"/>
-          <p:nvPr/>
-        </p:nvSpPr>
-        <p:spPr>
-          <a:xfrm>
-            <a:off x="16916400" y="9829800"/>
-            <a:ext cx="1097280" cy="320040"/>
-          </a:xfrm>
-          <a:prstGeom prst="rect">
-            <a:avLst/>
-          </a:prstGeom>
-          <a:noFill/>
-        </p:spPr>
-        <p:txBody>
-          <a:bodyPr wrap="square">
-            <a:spAutoFit/>
-          </a:bodyPr>
-          <a:lstStyle/>
-          <a:p>
-            <a:pPr algn="r"/>
-            <a:r>
-              <a:rPr sz="1000" b="0" i="0">
-                <a:solidFill>
-                  <a:srgbClr val="55657A"/>
-                </a:solidFill>
-                <a:latin typeface="Calibri Light"/>
-              </a:rPr>
-              <a:t>7 / 21</a:t>
-            </a:r>
-          </a:p>
-        </p:txBody>
-      </p:sp>
     </p:spTree>
   </p:cSld>
   <p:clrMapOvr>
@@ -14141,7 +14516,7 @@
 </file>
 
 <file path=ppt/slides/slide8.xml><?xml version="1.0" encoding="utf-8"?>
-<p:sld xmlns:a="http://schemas.openxmlformats.org/drawingml/2006/main" xmlns:p="http://schemas.openxmlformats.org/presentationml/2006/main" xmlns:r="http://schemas.openxmlformats.org/officeDocument/2006/relationships">
+<p:sld xmlns:a="http://schemas.openxmlformats.org/drawingml/2006/main" xmlns:r="http://schemas.openxmlformats.org/officeDocument/2006/relationships" xmlns:p="http://schemas.openxmlformats.org/presentationml/2006/main">
   <p:cSld>
     <p:bg>
       <p:bgPr>
@@ -14157,7 +14532,14 @@
         <p:cNvGrpSpPr/>
         <p:nvPr/>
       </p:nvGrpSpPr>
-      <p:grpSpPr/>
+      <p:grpSpPr>
+        <a:xfrm>
+          <a:off x="0" y="0"/>
+          <a:ext cx="0" cy="0"/>
+          <a:chOff x="0" y="0"/>
+          <a:chExt cx="0" cy="0"/>
+        </a:xfrm>
+      </p:grpSpPr>
       <p:sp>
         <p:nvSpPr>
           <p:cNvPr id="2" name="Rectangle 1"/>
@@ -14198,6 +14580,7 @@
           <a:lstStyle/>
           <a:p>
             <a:pPr algn="ctr"/>
+            <a:endParaRPr/>
           </a:p>
         </p:txBody>
       </p:sp>
@@ -14276,6 +14659,7 @@
           <a:lstStyle/>
           <a:p>
             <a:pPr algn="ctr"/>
+            <a:endParaRPr/>
           </a:p>
         </p:txBody>
       </p:sp>
@@ -14319,6 +14703,7 @@
           <a:lstStyle/>
           <a:p>
             <a:pPr algn="ctr"/>
+            <a:endParaRPr/>
           </a:p>
         </p:txBody>
       </p:sp>
@@ -14421,6 +14806,7 @@
           <a:lstStyle/>
           <a:p>
             <a:pPr algn="ctr"/>
+            <a:endParaRPr/>
           </a:p>
         </p:txBody>
       </p:sp>
@@ -14527,7 +14913,7 @@
 </file>
 
 <file path=ppt/slides/slide9.xml><?xml version="1.0" encoding="utf-8"?>
-<p:sld xmlns:a="http://schemas.openxmlformats.org/drawingml/2006/main" xmlns:p="http://schemas.openxmlformats.org/presentationml/2006/main" xmlns:r="http://schemas.openxmlformats.org/officeDocument/2006/relationships">
+<p:sld xmlns:a="http://schemas.openxmlformats.org/drawingml/2006/main" xmlns:r="http://schemas.openxmlformats.org/officeDocument/2006/relationships" xmlns:p="http://schemas.openxmlformats.org/presentationml/2006/main">
   <p:cSld>
     <p:bg>
       <p:bgPr>
@@ -14543,7 +14929,14 @@
         <p:cNvGrpSpPr/>
         <p:nvPr/>
       </p:nvGrpSpPr>
-      <p:grpSpPr/>
+      <p:grpSpPr>
+        <a:xfrm>
+          <a:off x="0" y="0"/>
+          <a:ext cx="0" cy="0"/>
+          <a:chOff x="0" y="0"/>
+          <a:chExt cx="0" cy="0"/>
+        </a:xfrm>
+      </p:grpSpPr>
       <p:sp>
         <p:nvSpPr>
           <p:cNvPr id="2" name="Rectangle 1"/>
@@ -14584,6 +14977,7 @@
           <a:lstStyle/>
           <a:p>
             <a:pPr algn="ctr"/>
+            <a:endParaRPr/>
           </a:p>
         </p:txBody>
       </p:sp>
@@ -14662,6 +15056,7 @@
           <a:lstStyle/>
           <a:p>
             <a:pPr algn="ctr"/>
+            <a:endParaRPr/>
           </a:p>
         </p:txBody>
       </p:sp>
@@ -14729,6 +15124,7 @@
           <a:lstStyle/>
           <a:p>
             <a:pPr algn="ctr"/>
+            <a:endParaRPr/>
           </a:p>
         </p:txBody>
       </p:sp>
@@ -14842,6 +15238,7 @@
           <a:lstStyle/>
           <a:p>
             <a:pPr algn="ctr"/>
+            <a:endParaRPr/>
           </a:p>
         </p:txBody>
       </p:sp>
@@ -14955,6 +15352,7 @@
           <a:lstStyle/>
           <a:p>
             <a:pPr algn="ctr"/>
+            <a:endParaRPr/>
           </a:p>
         </p:txBody>
       </p:sp>
@@ -15068,6 +15466,7 @@
           <a:lstStyle/>
           <a:p>
             <a:pPr algn="ctr"/>
+            <a:endParaRPr/>
           </a:p>
         </p:txBody>
       </p:sp>

</xml_diff>